<commit_message>
Gestión de Riesgo 23486 deck: fix overflow, larger text where space allows
Co-Authored-By: Claude Opus 5.5 <noreply@anthropic.com>
Claude-Session: https://claude.ai/code/session_01F1WXR13Nv8neEtLhaK3ELa
</commit_message>
<xml_diff>
--- a/supervision-gobierno-corporativo/Gestion_Riesgo_Especifico_DS-SABAO-BCS-BC-23486.pptx
+++ b/supervision-gobierno-corporativo/Gestion_Riesgo_Especifico_DS-SABAO-BCS-BC-23486.pptx
@@ -3178,11 +3178,11 @@
         <p:spPr>
           <a:xfrm>
             <a:off x="457200" y="1234440"/>
-            <a:ext cx="3673754" cy="1435167"/>
+            <a:ext cx="3673754" cy="1473409"/>
           </a:xfrm>
           <a:prstGeom prst="roundRect">
             <a:avLst>
-              <a:gd name="adj" fmla="val 6371"/>
+              <a:gd name="adj" fmla="val 6206"/>
             </a:avLst>
           </a:prstGeom>
           <a:solidFill>
@@ -3322,8 +3322,8 @@
         </p:nvSpPr>
         <p:spPr>
           <a:xfrm>
-            <a:off x="603504" y="1892808"/>
-            <a:ext cx="3381146" cy="372618"/>
+            <a:off x="603504" y="1911096"/>
+            <a:ext cx="3381146" cy="396621"/>
           </a:xfrm>
           <a:prstGeom prst="rect">
             <a:avLst/>
@@ -3339,14 +3339,14 @@
               <a:buNone/>
             </a:pPr>
             <a:r>
-              <a:rPr lang="en-US" sz="1050" b="1" dirty="0">
+              <a:rPr lang="en-US" sz="1125" b="1" dirty="0">
                 <a:solidFill>
                   <a:schemeClr val="accent1"/>
                 </a:solidFill>
               </a:rPr>
               <a:t>Deficiencias en la conformación y actualización de expedientes de clientes.</a:t>
             </a:r>
-            <a:endParaRPr lang="en-US" sz="1050" dirty="0"/>
+            <a:endParaRPr lang="en-US" sz="1125" dirty="0"/>
           </a:p>
         </p:txBody>
       </p:sp>
@@ -3358,8 +3358,8 @@
         </p:nvSpPr>
         <p:spPr>
           <a:xfrm>
-            <a:off x="603504" y="2338578"/>
-            <a:ext cx="3381146" cy="276165"/>
+            <a:off x="603504" y="2380869"/>
+            <a:ext cx="3381146" cy="235540"/>
           </a:xfrm>
           <a:prstGeom prst="rect">
             <a:avLst/>
@@ -3375,7 +3375,7 @@
               <a:buNone/>
             </a:pPr>
             <a:r>
-              <a:rPr lang="en-US" sz="950" b="1" dirty="0">
+              <a:rPr lang="en-US" sz="1025" b="1" dirty="0">
                 <a:solidFill>
                   <a:schemeClr val="accent5"/>
                 </a:solidFill>
@@ -3386,14 +3386,14 @@
               <a:buNone/>
             </a:pPr>
             <a:r>
-              <a:rPr lang="en-US" sz="950" b="1" dirty="0">
+              <a:rPr lang="en-US" sz="1025" b="1" dirty="0">
                 <a:solidFill>
                   <a:schemeClr val="accent6"/>
                 </a:solidFill>
               </a:rPr>
               <a:t>Pendiente</a:t>
             </a:r>
-            <a:endParaRPr lang="en-US" sz="950" dirty="0"/>
+            <a:endParaRPr lang="en-US" sz="1025" dirty="0"/>
           </a:p>
         </p:txBody>
       </p:sp>
@@ -3406,11 +3406,11 @@
         <p:spPr>
           <a:xfrm>
             <a:off x="4258970" y="1234440"/>
-            <a:ext cx="3673754" cy="1435167"/>
+            <a:ext cx="3673754" cy="1473409"/>
           </a:xfrm>
           <a:prstGeom prst="roundRect">
             <a:avLst>
-              <a:gd name="adj" fmla="val 6371"/>
+              <a:gd name="adj" fmla="val 6206"/>
             </a:avLst>
           </a:prstGeom>
           <a:solidFill>
@@ -3550,8 +3550,8 @@
         </p:nvSpPr>
         <p:spPr>
           <a:xfrm>
-            <a:off x="4405274" y="1892808"/>
-            <a:ext cx="3381146" cy="372618"/>
+            <a:off x="4405274" y="1911096"/>
+            <a:ext cx="3381146" cy="396621"/>
           </a:xfrm>
           <a:prstGeom prst="rect">
             <a:avLst/>
@@ -3567,14 +3567,14 @@
               <a:buNone/>
             </a:pPr>
             <a:r>
-              <a:rPr lang="en-US" sz="1050" b="1" dirty="0">
+              <a:rPr lang="en-US" sz="1125" b="1" dirty="0">
                 <a:solidFill>
                   <a:schemeClr val="accent1"/>
                 </a:solidFill>
               </a:rPr>
               <a:t>Deficiencias en la identificación de la actividad económica realizada por clientes.</a:t>
             </a:r>
-            <a:endParaRPr lang="en-US" sz="1050" dirty="0"/>
+            <a:endParaRPr lang="en-US" sz="1125" dirty="0"/>
           </a:p>
         </p:txBody>
       </p:sp>
@@ -3586,8 +3586,8 @@
         </p:nvSpPr>
         <p:spPr>
           <a:xfrm>
-            <a:off x="4405274" y="2338578"/>
-            <a:ext cx="3381146" cy="276165"/>
+            <a:off x="4405274" y="2380869"/>
+            <a:ext cx="3381146" cy="235540"/>
           </a:xfrm>
           <a:prstGeom prst="rect">
             <a:avLst/>
@@ -3603,7 +3603,7 @@
               <a:buNone/>
             </a:pPr>
             <a:r>
-              <a:rPr lang="en-US" sz="950" b="1" dirty="0">
+              <a:rPr lang="en-US" sz="1025" b="1" dirty="0">
                 <a:solidFill>
                   <a:schemeClr val="accent5"/>
                 </a:solidFill>
@@ -3614,14 +3614,14 @@
               <a:buNone/>
             </a:pPr>
             <a:r>
-              <a:rPr lang="en-US" sz="950" b="1" dirty="0">
+              <a:rPr lang="en-US" sz="1025" b="1" dirty="0">
                 <a:solidFill>
                   <a:schemeClr val="accent6"/>
                 </a:solidFill>
               </a:rPr>
               <a:t>Pendiente</a:t>
             </a:r>
-            <a:endParaRPr lang="en-US" sz="950" dirty="0"/>
+            <a:endParaRPr lang="en-US" sz="1025" dirty="0"/>
           </a:p>
         </p:txBody>
       </p:sp>
@@ -3634,11 +3634,11 @@
         <p:spPr>
           <a:xfrm>
             <a:off x="8060741" y="1234440"/>
-            <a:ext cx="3673754" cy="1435167"/>
+            <a:ext cx="3673754" cy="1473409"/>
           </a:xfrm>
           <a:prstGeom prst="roundRect">
             <a:avLst>
-              <a:gd name="adj" fmla="val 6371"/>
+              <a:gd name="adj" fmla="val 6206"/>
             </a:avLst>
           </a:prstGeom>
           <a:solidFill>
@@ -3778,8 +3778,8 @@
         </p:nvSpPr>
         <p:spPr>
           <a:xfrm>
-            <a:off x="8207045" y="1892808"/>
-            <a:ext cx="3381146" cy="372618"/>
+            <a:off x="8207045" y="1911096"/>
+            <a:ext cx="3381146" cy="396621"/>
           </a:xfrm>
           <a:prstGeom prst="rect">
             <a:avLst/>
@@ -3795,14 +3795,14 @@
               <a:buNone/>
             </a:pPr>
             <a:r>
-              <a:rPr lang="en-US" sz="1050" b="1" dirty="0">
+              <a:rPr lang="en-US" sz="1125" b="1" dirty="0">
                 <a:solidFill>
                   <a:schemeClr val="accent1"/>
                 </a:solidFill>
               </a:rPr>
               <a:t>Falta de actualización de Metodología y matriz de riesgo LA/FT/FPADM de la Entidad</a:t>
             </a:r>
-            <a:endParaRPr lang="en-US" sz="1050" dirty="0"/>
+            <a:endParaRPr lang="en-US" sz="1125" dirty="0"/>
           </a:p>
         </p:txBody>
       </p:sp>
@@ -3814,8 +3814,8 @@
         </p:nvSpPr>
         <p:spPr>
           <a:xfrm>
-            <a:off x="8207045" y="2338578"/>
-            <a:ext cx="3381146" cy="276165"/>
+            <a:off x="8207045" y="2380869"/>
+            <a:ext cx="3381146" cy="235540"/>
           </a:xfrm>
           <a:prstGeom prst="rect">
             <a:avLst/>
@@ -3831,7 +3831,7 @@
               <a:buNone/>
             </a:pPr>
             <a:r>
-              <a:rPr lang="en-US" sz="950" b="1" dirty="0">
+              <a:rPr lang="en-US" sz="1025" b="1" dirty="0">
                 <a:solidFill>
                   <a:schemeClr val="accent5"/>
                 </a:solidFill>
@@ -3842,14 +3842,14 @@
               <a:buNone/>
             </a:pPr>
             <a:r>
-              <a:rPr lang="en-US" sz="950" b="1" dirty="0">
+              <a:rPr lang="en-US" sz="1025" b="1" dirty="0">
                 <a:solidFill>
                   <a:schemeClr val="accent6"/>
                 </a:solidFill>
               </a:rPr>
               <a:t>Pendiente</a:t>
             </a:r>
-            <a:endParaRPr lang="en-US" sz="950" dirty="0"/>
+            <a:endParaRPr lang="en-US" sz="1025" dirty="0"/>
           </a:p>
         </p:txBody>
       </p:sp>
@@ -3861,12 +3861,12 @@
         </p:nvSpPr>
         <p:spPr>
           <a:xfrm>
-            <a:off x="457200" y="2797623"/>
-            <a:ext cx="3673754" cy="1435167"/>
+            <a:off x="457200" y="2835865"/>
+            <a:ext cx="3673754" cy="1473409"/>
           </a:xfrm>
           <a:prstGeom prst="roundRect">
             <a:avLst>
-              <a:gd name="adj" fmla="val 6371"/>
+              <a:gd name="adj" fmla="val 6206"/>
             </a:avLst>
           </a:prstGeom>
           <a:solidFill>
@@ -3890,7 +3890,7 @@
         </p:nvSpPr>
         <p:spPr>
           <a:xfrm>
-            <a:off x="566928" y="2907351"/>
+            <a:off x="566928" y="2945593"/>
             <a:ext cx="457200" cy="457200"/>
           </a:xfrm>
           <a:prstGeom prst="ellipse">
@@ -3917,7 +3917,7 @@
         </p:nvSpPr>
         <p:spPr>
           <a:xfrm>
-            <a:off x="566928" y="2907351"/>
+            <a:off x="566928" y="2945593"/>
             <a:ext cx="457200" cy="457200"/>
           </a:xfrm>
           <a:prstGeom prst="rect">
@@ -3956,7 +3956,7 @@
         </p:nvSpPr>
         <p:spPr>
           <a:xfrm>
-            <a:off x="1115568" y="2870775"/>
+            <a:off x="1115568" y="2909017"/>
             <a:ext cx="2905658" cy="512064"/>
           </a:xfrm>
           <a:prstGeom prst="rect">
@@ -4006,8 +4006,8 @@
         </p:nvSpPr>
         <p:spPr>
           <a:xfrm>
-            <a:off x="603504" y="3455991"/>
-            <a:ext cx="3381146" cy="372618"/>
+            <a:off x="603504" y="3512521"/>
+            <a:ext cx="3381146" cy="396621"/>
           </a:xfrm>
           <a:prstGeom prst="rect">
             <a:avLst/>
@@ -4023,14 +4023,14 @@
               <a:buNone/>
             </a:pPr>
             <a:r>
-              <a:rPr lang="en-US" sz="1050" b="1" dirty="0">
+              <a:rPr lang="en-US" sz="1125" b="1" dirty="0">
                 <a:solidFill>
                   <a:schemeClr val="accent1"/>
                 </a:solidFill>
               </a:rPr>
               <a:t>Falta de actualización de Metodología y matriz de riesgo LA/FT/FPADM Clientes o asociados</a:t>
             </a:r>
-            <a:endParaRPr lang="en-US" sz="1050" dirty="0"/>
+            <a:endParaRPr lang="en-US" sz="1125" dirty="0"/>
           </a:p>
         </p:txBody>
       </p:sp>
@@ -4042,8 +4042,8 @@
         </p:nvSpPr>
         <p:spPr>
           <a:xfrm>
-            <a:off x="603504" y="3901761"/>
-            <a:ext cx="3381146" cy="276165"/>
+            <a:off x="603504" y="3982294"/>
+            <a:ext cx="3381146" cy="235540"/>
           </a:xfrm>
           <a:prstGeom prst="rect">
             <a:avLst/>
@@ -4059,7 +4059,7 @@
               <a:buNone/>
             </a:pPr>
             <a:r>
-              <a:rPr lang="en-US" sz="950" b="1" dirty="0">
+              <a:rPr lang="en-US" sz="1025" b="1" dirty="0">
                 <a:solidFill>
                   <a:schemeClr val="accent5"/>
                 </a:solidFill>
@@ -4070,14 +4070,14 @@
               <a:buNone/>
             </a:pPr>
             <a:r>
-              <a:rPr lang="en-US" sz="950" b="1" dirty="0">
+              <a:rPr lang="en-US" sz="1025" b="1" dirty="0">
                 <a:solidFill>
                   <a:schemeClr val="accent6"/>
                 </a:solidFill>
               </a:rPr>
               <a:t>Pendiente</a:t>
             </a:r>
-            <a:endParaRPr lang="en-US" sz="950" dirty="0"/>
+            <a:endParaRPr lang="en-US" sz="1025" dirty="0"/>
           </a:p>
         </p:txBody>
       </p:sp>
@@ -4089,12 +4089,12 @@
         </p:nvSpPr>
         <p:spPr>
           <a:xfrm>
-            <a:off x="4258970" y="2797623"/>
-            <a:ext cx="3673754" cy="1435167"/>
+            <a:off x="4258970" y="2835865"/>
+            <a:ext cx="3673754" cy="1473409"/>
           </a:xfrm>
           <a:prstGeom prst="roundRect">
             <a:avLst>
-              <a:gd name="adj" fmla="val 6371"/>
+              <a:gd name="adj" fmla="val 6206"/>
             </a:avLst>
           </a:prstGeom>
           <a:solidFill>
@@ -4118,7 +4118,7 @@
         </p:nvSpPr>
         <p:spPr>
           <a:xfrm>
-            <a:off x="4368698" y="2907351"/>
+            <a:off x="4368698" y="2945593"/>
             <a:ext cx="457200" cy="457200"/>
           </a:xfrm>
           <a:prstGeom prst="ellipse">
@@ -4145,7 +4145,7 @@
         </p:nvSpPr>
         <p:spPr>
           <a:xfrm>
-            <a:off x="4368698" y="2907351"/>
+            <a:off x="4368698" y="2945593"/>
             <a:ext cx="457200" cy="457200"/>
           </a:xfrm>
           <a:prstGeom prst="rect">
@@ -4184,7 +4184,7 @@
         </p:nvSpPr>
         <p:spPr>
           <a:xfrm>
-            <a:off x="4917338" y="2870775"/>
+            <a:off x="4917338" y="2909017"/>
             <a:ext cx="2905658" cy="512064"/>
           </a:xfrm>
           <a:prstGeom prst="rect">
@@ -4234,8 +4234,8 @@
         </p:nvSpPr>
         <p:spPr>
           <a:xfrm>
-            <a:off x="4405274" y="3455991"/>
-            <a:ext cx="3381146" cy="372618"/>
+            <a:off x="4405274" y="3512521"/>
+            <a:ext cx="3381146" cy="396621"/>
           </a:xfrm>
           <a:prstGeom prst="rect">
             <a:avLst/>
@@ -4251,14 +4251,14 @@
               <a:buNone/>
             </a:pPr>
             <a:r>
-              <a:rPr lang="en-US" sz="1050" b="1" dirty="0">
+              <a:rPr lang="en-US" sz="1125" b="1" dirty="0">
                 <a:solidFill>
                   <a:schemeClr val="accent1"/>
                 </a:solidFill>
               </a:rPr>
               <a:t>Falta de automatización en el proceso de remisión de reportería regulada a la Web Service de UIF.</a:t>
             </a:r>
-            <a:endParaRPr lang="en-US" sz="1050" dirty="0"/>
+            <a:endParaRPr lang="en-US" sz="1125" dirty="0"/>
           </a:p>
         </p:txBody>
       </p:sp>
@@ -4270,8 +4270,8 @@
         </p:nvSpPr>
         <p:spPr>
           <a:xfrm>
-            <a:off x="4405274" y="3901761"/>
-            <a:ext cx="3381146" cy="276165"/>
+            <a:off x="4405274" y="3982294"/>
+            <a:ext cx="3381146" cy="235540"/>
           </a:xfrm>
           <a:prstGeom prst="rect">
             <a:avLst/>
@@ -4287,7 +4287,7 @@
               <a:buNone/>
             </a:pPr>
             <a:r>
-              <a:rPr lang="en-US" sz="950" b="1" dirty="0">
+              <a:rPr lang="en-US" sz="1025" b="1" dirty="0">
                 <a:solidFill>
                   <a:schemeClr val="accent5"/>
                 </a:solidFill>
@@ -4298,14 +4298,14 @@
               <a:buNone/>
             </a:pPr>
             <a:r>
-              <a:rPr lang="en-US" sz="950" b="1" dirty="0">
+              <a:rPr lang="en-US" sz="1025" b="1" dirty="0">
                 <a:solidFill>
                   <a:schemeClr val="accent6"/>
                 </a:solidFill>
               </a:rPr>
               <a:t>Pendiente</a:t>
             </a:r>
-            <a:endParaRPr lang="en-US" sz="950" dirty="0"/>
+            <a:endParaRPr lang="en-US" sz="1025" dirty="0"/>
           </a:p>
         </p:txBody>
       </p:sp>
@@ -4317,12 +4317,12 @@
         </p:nvSpPr>
         <p:spPr>
           <a:xfrm>
-            <a:off x="8060741" y="2797623"/>
-            <a:ext cx="3673754" cy="1435167"/>
+            <a:off x="8060741" y="2835865"/>
+            <a:ext cx="3673754" cy="1473409"/>
           </a:xfrm>
           <a:prstGeom prst="roundRect">
             <a:avLst>
-              <a:gd name="adj" fmla="val 6371"/>
+              <a:gd name="adj" fmla="val 6206"/>
             </a:avLst>
           </a:prstGeom>
           <a:solidFill>
@@ -4346,7 +4346,7 @@
         </p:nvSpPr>
         <p:spPr>
           <a:xfrm>
-            <a:off x="8170469" y="2907351"/>
+            <a:off x="8170469" y="2945593"/>
             <a:ext cx="457200" cy="457200"/>
           </a:xfrm>
           <a:prstGeom prst="ellipse">
@@ -4373,7 +4373,7 @@
         </p:nvSpPr>
         <p:spPr>
           <a:xfrm>
-            <a:off x="8170469" y="2907351"/>
+            <a:off x="8170469" y="2945593"/>
             <a:ext cx="457200" cy="457200"/>
           </a:xfrm>
           <a:prstGeom prst="rect">
@@ -4412,7 +4412,7 @@
         </p:nvSpPr>
         <p:spPr>
           <a:xfrm>
-            <a:off x="8719109" y="2870775"/>
+            <a:off x="8719109" y="2909017"/>
             <a:ext cx="2905658" cy="512064"/>
           </a:xfrm>
           <a:prstGeom prst="rect">
@@ -4462,8 +4462,8 @@
         </p:nvSpPr>
         <p:spPr>
           <a:xfrm>
-            <a:off x="8207045" y="3455991"/>
-            <a:ext cx="3381146" cy="372618"/>
+            <a:off x="8207045" y="3512521"/>
+            <a:ext cx="3381146" cy="396621"/>
           </a:xfrm>
           <a:prstGeom prst="rect">
             <a:avLst/>
@@ -4479,14 +4479,14 @@
               <a:buNone/>
             </a:pPr>
             <a:r>
-              <a:rPr lang="en-US" sz="1050" b="1" dirty="0">
+              <a:rPr lang="en-US" sz="1125" b="1" dirty="0">
                 <a:solidFill>
                   <a:schemeClr val="accent1"/>
                 </a:solidFill>
               </a:rPr>
               <a:t>Falta de Automatización de la herramienta de validación de Listas de Cautela</a:t>
             </a:r>
-            <a:endParaRPr lang="en-US" sz="1050" dirty="0"/>
+            <a:endParaRPr lang="en-US" sz="1125" dirty="0"/>
           </a:p>
         </p:txBody>
       </p:sp>
@@ -4498,8 +4498,8 @@
         </p:nvSpPr>
         <p:spPr>
           <a:xfrm>
-            <a:off x="8207045" y="3901761"/>
-            <a:ext cx="3381146" cy="276165"/>
+            <a:off x="8207045" y="3982294"/>
+            <a:ext cx="3381146" cy="235540"/>
           </a:xfrm>
           <a:prstGeom prst="rect">
             <a:avLst/>
@@ -4515,7 +4515,7 @@
               <a:buNone/>
             </a:pPr>
             <a:r>
-              <a:rPr lang="en-US" sz="950" b="1" dirty="0">
+              <a:rPr lang="en-US" sz="1025" b="1" dirty="0">
                 <a:solidFill>
                   <a:schemeClr val="accent5"/>
                 </a:solidFill>
@@ -4526,14 +4526,14 @@
               <a:buNone/>
             </a:pPr>
             <a:r>
-              <a:rPr lang="en-US" sz="950" b="1" dirty="0">
+              <a:rPr lang="en-US" sz="1025" b="1" dirty="0">
                 <a:solidFill>
                   <a:schemeClr val="accent6"/>
                 </a:solidFill>
               </a:rPr>
               <a:t>Pendiente</a:t>
             </a:r>
-            <a:endParaRPr lang="en-US" sz="950" dirty="0"/>
+            <a:endParaRPr lang="en-US" sz="1025" dirty="0"/>
           </a:p>
         </p:txBody>
       </p:sp>
@@ -4545,12 +4545,12 @@
         </p:nvSpPr>
         <p:spPr>
           <a:xfrm>
-            <a:off x="457200" y="4360806"/>
-            <a:ext cx="3673754" cy="2039994"/>
+            <a:off x="457200" y="4437290"/>
+            <a:ext cx="3673754" cy="1963510"/>
           </a:xfrm>
           <a:prstGeom prst="roundRect">
             <a:avLst>
-              <a:gd name="adj" fmla="val 4482"/>
+              <a:gd name="adj" fmla="val 4657"/>
             </a:avLst>
           </a:prstGeom>
           <a:solidFill>
@@ -4574,7 +4574,7 @@
         </p:nvSpPr>
         <p:spPr>
           <a:xfrm>
-            <a:off x="566928" y="4470534"/>
+            <a:off x="566928" y="4547018"/>
             <a:ext cx="457200" cy="457200"/>
           </a:xfrm>
           <a:prstGeom prst="ellipse">
@@ -4601,7 +4601,7 @@
         </p:nvSpPr>
         <p:spPr>
           <a:xfrm>
-            <a:off x="566928" y="4470534"/>
+            <a:off x="566928" y="4547018"/>
             <a:ext cx="457200" cy="457200"/>
           </a:xfrm>
           <a:prstGeom prst="rect">
@@ -4640,7 +4640,7 @@
         </p:nvSpPr>
         <p:spPr>
           <a:xfrm>
-            <a:off x="1115568" y="4433958"/>
+            <a:off x="1115568" y="4510442"/>
             <a:ext cx="2905658" cy="512064"/>
           </a:xfrm>
           <a:prstGeom prst="rect">
@@ -4690,8 +4690,8 @@
         </p:nvSpPr>
         <p:spPr>
           <a:xfrm>
-            <a:off x="603504" y="5019174"/>
-            <a:ext cx="3381146" cy="372618"/>
+            <a:off x="603504" y="5113946"/>
+            <a:ext cx="3381146" cy="396621"/>
           </a:xfrm>
           <a:prstGeom prst="rect">
             <a:avLst/>
@@ -4707,14 +4707,14 @@
               <a:buNone/>
             </a:pPr>
             <a:r>
-              <a:rPr lang="en-US" sz="1050" b="1" dirty="0">
+              <a:rPr lang="en-US" sz="1125" b="1" dirty="0">
                 <a:solidFill>
                   <a:schemeClr val="accent1"/>
                 </a:solidFill>
               </a:rPr>
               <a:t>Falta de evidencia en los porcentajes de avance comunicados en el cronograma</a:t>
             </a:r>
-            <a:endParaRPr lang="en-US" sz="1050" dirty="0"/>
+            <a:endParaRPr lang="en-US" sz="1125" dirty="0"/>
           </a:p>
         </p:txBody>
       </p:sp>
@@ -4726,8 +4726,8 @@
         </p:nvSpPr>
         <p:spPr>
           <a:xfrm>
-            <a:off x="603504" y="5464944"/>
-            <a:ext cx="3381146" cy="880992"/>
+            <a:off x="603504" y="5583719"/>
+            <a:ext cx="3381146" cy="725641"/>
           </a:xfrm>
           <a:prstGeom prst="rect">
             <a:avLst/>
@@ -4743,7 +4743,7 @@
               <a:buNone/>
             </a:pPr>
             <a:r>
-              <a:rPr lang="en-US" sz="950" b="1" dirty="0">
+              <a:rPr lang="en-US" sz="1025" b="1" dirty="0">
                 <a:solidFill>
                   <a:schemeClr val="accent5"/>
                 </a:solidFill>
@@ -4754,14 +4754,14 @@
               <a:buNone/>
             </a:pPr>
             <a:r>
-              <a:rPr lang="en-US" sz="950" b="1" dirty="0">
+              <a:rPr lang="en-US" sz="1025" b="1" dirty="0">
                 <a:solidFill>
                   <a:schemeClr val="accent6"/>
                 </a:solidFill>
               </a:rPr>
               <a:t>Pendiente</a:t>
             </a:r>
-            <a:endParaRPr lang="en-US" sz="950" dirty="0"/>
+            <a:endParaRPr lang="en-US" sz="1025" dirty="0"/>
           </a:p>
         </p:txBody>
       </p:sp>
@@ -4773,12 +4773,12 @@
         </p:nvSpPr>
         <p:spPr>
           <a:xfrm>
-            <a:off x="4258970" y="4360806"/>
-            <a:ext cx="3673754" cy="2039994"/>
+            <a:off x="4258970" y="4437290"/>
+            <a:ext cx="3673754" cy="1963510"/>
           </a:xfrm>
           <a:prstGeom prst="roundRect">
             <a:avLst>
-              <a:gd name="adj" fmla="val 4482"/>
+              <a:gd name="adj" fmla="val 4657"/>
             </a:avLst>
           </a:prstGeom>
           <a:solidFill>
@@ -4802,7 +4802,7 @@
         </p:nvSpPr>
         <p:spPr>
           <a:xfrm>
-            <a:off x="4368698" y="4470534"/>
+            <a:off x="4368698" y="4547018"/>
             <a:ext cx="457200" cy="457200"/>
           </a:xfrm>
           <a:prstGeom prst="ellipse">
@@ -4829,7 +4829,7 @@
         </p:nvSpPr>
         <p:spPr>
           <a:xfrm>
-            <a:off x="4368698" y="4470534"/>
+            <a:off x="4368698" y="4547018"/>
             <a:ext cx="457200" cy="457200"/>
           </a:xfrm>
           <a:prstGeom prst="rect">
@@ -4868,7 +4868,7 @@
         </p:nvSpPr>
         <p:spPr>
           <a:xfrm>
-            <a:off x="4917338" y="4433958"/>
+            <a:off x="4917338" y="4510442"/>
             <a:ext cx="2905658" cy="512064"/>
           </a:xfrm>
           <a:prstGeom prst="rect">
@@ -4918,8 +4918,8 @@
         </p:nvSpPr>
         <p:spPr>
           <a:xfrm>
-            <a:off x="4405274" y="5019174"/>
-            <a:ext cx="3381146" cy="372618"/>
+            <a:off x="4405274" y="5113946"/>
+            <a:ext cx="3381146" cy="396621"/>
           </a:xfrm>
           <a:prstGeom prst="rect">
             <a:avLst/>
@@ -4935,14 +4935,14 @@
               <a:buNone/>
             </a:pPr>
             <a:r>
-              <a:rPr lang="en-US" sz="1050" b="1" dirty="0">
+              <a:rPr lang="en-US" sz="1125" b="1" dirty="0">
                 <a:solidFill>
                   <a:schemeClr val="accent1"/>
                 </a:solidFill>
               </a:rPr>
               <a:t>Revisión documentación conforme artículo22 de la NRP-23</a:t>
             </a:r>
-            <a:endParaRPr lang="en-US" sz="1050" dirty="0"/>
+            <a:endParaRPr lang="en-US" sz="1125" dirty="0"/>
           </a:p>
         </p:txBody>
       </p:sp>
@@ -4954,8 +4954,8 @@
         </p:nvSpPr>
         <p:spPr>
           <a:xfrm>
-            <a:off x="4405274" y="5464944"/>
-            <a:ext cx="3381146" cy="880992"/>
+            <a:off x="4405274" y="5583719"/>
+            <a:ext cx="3381146" cy="725641"/>
           </a:xfrm>
           <a:prstGeom prst="rect">
             <a:avLst/>
@@ -4971,7 +4971,7 @@
               <a:buNone/>
             </a:pPr>
             <a:r>
-              <a:rPr lang="en-US" sz="950" b="1" dirty="0">
+              <a:rPr lang="en-US" sz="1025" b="1" dirty="0">
                 <a:solidFill>
                   <a:schemeClr val="accent5"/>
                 </a:solidFill>
@@ -4982,14 +4982,14 @@
               <a:buNone/>
             </a:pPr>
             <a:r>
-              <a:rPr lang="en-US" sz="950" dirty="0">
+              <a:rPr lang="en-US" sz="1025" dirty="0">
                 <a:solidFill>
                   <a:schemeClr val="tx1"/>
                 </a:solidFill>
               </a:rPr>
               <a:t>Se anexa informe elaborado en fecha 13 de diciembre de 2024, sobre proyecto de implementación de un nuevo sistema de monitoreo de LDA/FT/FPADM y del sistema de fraude de canales digitales.</a:t>
             </a:r>
-            <a:endParaRPr lang="en-US" sz="950" dirty="0"/>
+            <a:endParaRPr lang="en-US" sz="1025" dirty="0"/>
           </a:p>
         </p:txBody>
       </p:sp>
@@ -5001,12 +5001,12 @@
         </p:nvSpPr>
         <p:spPr>
           <a:xfrm>
-            <a:off x="8060741" y="4360806"/>
-            <a:ext cx="3673754" cy="2039994"/>
+            <a:off x="8060741" y="4437290"/>
+            <a:ext cx="3673754" cy="1963510"/>
           </a:xfrm>
           <a:prstGeom prst="roundRect">
             <a:avLst>
-              <a:gd name="adj" fmla="val 4482"/>
+              <a:gd name="adj" fmla="val 4657"/>
             </a:avLst>
           </a:prstGeom>
           <a:solidFill>
@@ -5030,7 +5030,7 @@
         </p:nvSpPr>
         <p:spPr>
           <a:xfrm>
-            <a:off x="8170469" y="4470534"/>
+            <a:off x="8170469" y="4547018"/>
             <a:ext cx="457200" cy="457200"/>
           </a:xfrm>
           <a:prstGeom prst="ellipse">
@@ -5057,7 +5057,7 @@
         </p:nvSpPr>
         <p:spPr>
           <a:xfrm>
-            <a:off x="8170469" y="4470534"/>
+            <a:off x="8170469" y="4547018"/>
             <a:ext cx="457200" cy="457200"/>
           </a:xfrm>
           <a:prstGeom prst="rect">
@@ -5096,7 +5096,7 @@
         </p:nvSpPr>
         <p:spPr>
           <a:xfrm>
-            <a:off x="8719109" y="4433958"/>
+            <a:off x="8719109" y="4510442"/>
             <a:ext cx="2905658" cy="512064"/>
           </a:xfrm>
           <a:prstGeom prst="rect">
@@ -5160,8 +5160,8 @@
         </p:nvSpPr>
         <p:spPr>
           <a:xfrm>
-            <a:off x="8207045" y="5019174"/>
-            <a:ext cx="3381146" cy="372618"/>
+            <a:off x="8207045" y="5113946"/>
+            <a:ext cx="3381146" cy="216599"/>
           </a:xfrm>
           <a:prstGeom prst="rect">
             <a:avLst/>
@@ -5177,14 +5177,14 @@
               <a:buNone/>
             </a:pPr>
             <a:r>
-              <a:rPr lang="en-US" sz="1050" b="1" dirty="0">
+              <a:rPr lang="en-US" sz="1125" b="1" dirty="0">
                 <a:solidFill>
                   <a:schemeClr val="accent1"/>
                 </a:solidFill>
               </a:rPr>
               <a:t>Debilidades en el contrato del servicio de software</a:t>
             </a:r>
-            <a:endParaRPr lang="en-US" sz="1050" dirty="0"/>
+            <a:endParaRPr lang="en-US" sz="1125" dirty="0"/>
           </a:p>
         </p:txBody>
       </p:sp>
@@ -5196,8 +5196,8 @@
         </p:nvSpPr>
         <p:spPr>
           <a:xfrm>
-            <a:off x="8207045" y="5464944"/>
-            <a:ext cx="3381146" cy="880992"/>
+            <a:off x="8207045" y="5403696"/>
+            <a:ext cx="3381146" cy="905664"/>
           </a:xfrm>
           <a:prstGeom prst="rect">
             <a:avLst/>
@@ -5213,7 +5213,7 @@
               <a:buNone/>
             </a:pPr>
             <a:r>
-              <a:rPr lang="en-US" sz="950" b="1" dirty="0">
+              <a:rPr lang="en-US" sz="1025" b="1" dirty="0">
                 <a:solidFill>
                   <a:schemeClr val="accent5"/>
                 </a:solidFill>
@@ -5224,14 +5224,14 @@
               <a:buNone/>
             </a:pPr>
             <a:r>
-              <a:rPr lang="en-US" sz="950" dirty="0">
+              <a:rPr lang="en-US" sz="1025" dirty="0">
                 <a:solidFill>
                   <a:schemeClr val="tx1"/>
                 </a:solidFill>
               </a:rPr>
               <a:t>Se adjuntará la propuesta de la Gerencia Legal por medio de correo de fecha 09 de octubre 2026, envió propuesta a la Gerencia de Cumplimiento y Seguridad de la Información para la modificación del contrato. Pendiente</a:t>
             </a:r>
-            <a:endParaRPr lang="en-US" sz="950" dirty="0"/>
+            <a:endParaRPr lang="en-US" sz="1025" dirty="0"/>
           </a:p>
         </p:txBody>
       </p:sp>
@@ -5413,11 +5413,11 @@
         <p:spPr>
           <a:xfrm>
             <a:off x="457200" y="1234440"/>
-            <a:ext cx="2723312" cy="2275096"/>
+            <a:ext cx="2723312" cy="2406159"/>
           </a:xfrm>
           <a:prstGeom prst="roundRect">
             <a:avLst>
-              <a:gd name="adj" fmla="val 4019"/>
+              <a:gd name="adj" fmla="val 3800"/>
             </a:avLst>
           </a:prstGeom>
           <a:solidFill>
@@ -5508,7 +5508,7 @@
         <p:spPr>
           <a:xfrm>
             <a:off x="1115568" y="1307592"/>
-            <a:ext cx="1955216" cy="512064"/>
+            <a:ext cx="1955216" cy="649224"/>
           </a:xfrm>
           <a:prstGeom prst="rect">
             <a:avLst/>
@@ -5557,8 +5557,8 @@
         </p:nvSpPr>
         <p:spPr>
           <a:xfrm>
-            <a:off x="603504" y="1892808"/>
-            <a:ext cx="2430704" cy="316611"/>
+            <a:off x="603504" y="2048256"/>
+            <a:ext cx="2430704" cy="324612"/>
           </a:xfrm>
           <a:prstGeom prst="rect">
             <a:avLst/>
@@ -5574,14 +5574,14 @@
               <a:buNone/>
             </a:pPr>
             <a:r>
-              <a:rPr lang="en-US" sz="875" b="1" dirty="0">
+              <a:rPr lang="en-US" sz="900" b="1" dirty="0">
                 <a:solidFill>
                   <a:schemeClr val="accent1"/>
                 </a:solidFill>
               </a:rPr>
               <a:t>Debilidad en el Alcance de las Pruebas Continuidad del Negocio</a:t>
             </a:r>
-            <a:endParaRPr lang="en-US" sz="875" dirty="0"/>
+            <a:endParaRPr lang="en-US" sz="900" dirty="0"/>
           </a:p>
         </p:txBody>
       </p:sp>
@@ -5593,8 +5593,8 @@
         </p:nvSpPr>
         <p:spPr>
           <a:xfrm>
-            <a:off x="603504" y="2282571"/>
-            <a:ext cx="2430704" cy="1172101"/>
+            <a:off x="603504" y="2446020"/>
+            <a:ext cx="2430704" cy="1103139"/>
           </a:xfrm>
           <a:prstGeom prst="rect">
             <a:avLst/>
@@ -5610,7 +5610,7 @@
               <a:buNone/>
             </a:pPr>
             <a:r>
-              <a:rPr lang="en-US" sz="775" b="1" dirty="0">
+              <a:rPr lang="en-US" sz="800" b="1" dirty="0">
                 <a:solidFill>
                   <a:schemeClr val="accent5"/>
                 </a:solidFill>
@@ -5621,14 +5621,14 @@
               <a:buNone/>
             </a:pPr>
             <a:r>
-              <a:rPr lang="en-US" sz="775" dirty="0">
+              <a:rPr lang="en-US" sz="800" dirty="0">
                 <a:solidFill>
                   <a:schemeClr val="tx1"/>
                 </a:solidFill>
               </a:rPr>
               <a:t>Plan de acción: proveedor critico Pendiente Se identificarán los servicios tecnológicos tercerizados críticos y se incorporarán en el alcance de las pruebas de continuidad del negocio. Asimismo, se solicitarán a los proveedores los resultados y evidencias de las pruebas realizadas, con el fin de validar la efectividad de los controles implementados.</a:t>
             </a:r>
-            <a:endParaRPr lang="en-US" sz="775" dirty="0"/>
+            <a:endParaRPr lang="en-US" sz="800" dirty="0"/>
           </a:p>
         </p:txBody>
       </p:sp>
@@ -5641,11 +5641,11 @@
         <p:spPr>
           <a:xfrm>
             <a:off x="3308528" y="1234440"/>
-            <a:ext cx="2723312" cy="2275096"/>
+            <a:ext cx="2723312" cy="2406159"/>
           </a:xfrm>
           <a:prstGeom prst="roundRect">
             <a:avLst>
-              <a:gd name="adj" fmla="val 4019"/>
+              <a:gd name="adj" fmla="val 3800"/>
             </a:avLst>
           </a:prstGeom>
           <a:solidFill>
@@ -5799,8 +5799,8 @@
         </p:nvSpPr>
         <p:spPr>
           <a:xfrm>
-            <a:off x="3454832" y="1892808"/>
-            <a:ext cx="2430704" cy="316611"/>
+            <a:off x="3454832" y="1911096"/>
+            <a:ext cx="2430704" cy="324612"/>
           </a:xfrm>
           <a:prstGeom prst="rect">
             <a:avLst/>
@@ -5816,14 +5816,14 @@
               <a:buNone/>
             </a:pPr>
             <a:r>
-              <a:rPr lang="en-US" sz="875" b="1" dirty="0">
+              <a:rPr lang="en-US" sz="900" b="1" dirty="0">
                 <a:solidFill>
                   <a:schemeClr val="accent1"/>
                 </a:solidFill>
               </a:rPr>
               <a:t>Deficiencia en los procedimientos de Respaldos.</a:t>
             </a:r>
-            <a:endParaRPr lang="en-US" sz="875" dirty="0"/>
+            <a:endParaRPr lang="en-US" sz="900" dirty="0"/>
           </a:p>
         </p:txBody>
       </p:sp>
@@ -5835,8 +5835,8 @@
         </p:nvSpPr>
         <p:spPr>
           <a:xfrm>
-            <a:off x="3454832" y="2282571"/>
-            <a:ext cx="2430704" cy="1172101"/>
+            <a:off x="3454832" y="2308860"/>
+            <a:ext cx="2430704" cy="1240299"/>
           </a:xfrm>
           <a:prstGeom prst="rect">
             <a:avLst/>
@@ -5852,7 +5852,7 @@
               <a:buNone/>
             </a:pPr>
             <a:r>
-              <a:rPr lang="en-US" sz="775" b="1" dirty="0">
+              <a:rPr lang="en-US" sz="800" b="1" dirty="0">
                 <a:solidFill>
                   <a:schemeClr val="accent5"/>
                 </a:solidFill>
@@ -5863,14 +5863,14 @@
               <a:buNone/>
             </a:pPr>
             <a:r>
-              <a:rPr lang="en-US" sz="775" dirty="0">
+              <a:rPr lang="en-US" sz="800" dirty="0">
                 <a:solidFill>
                   <a:schemeClr val="tx1"/>
                 </a:solidFill>
               </a:rPr>
               <a:t>Plan de acción Pendiente</a:t>
             </a:r>
-            <a:endParaRPr lang="en-US" sz="775" dirty="0"/>
+            <a:endParaRPr lang="en-US" sz="800" dirty="0"/>
           </a:p>
         </p:txBody>
       </p:sp>
@@ -5883,11 +5883,11 @@
         <p:spPr>
           <a:xfrm>
             <a:off x="6159856" y="1234440"/>
-            <a:ext cx="2723312" cy="2275096"/>
+            <a:ext cx="2723312" cy="2406159"/>
           </a:xfrm>
           <a:prstGeom prst="roundRect">
             <a:avLst>
-              <a:gd name="adj" fmla="val 4019"/>
+              <a:gd name="adj" fmla="val 3800"/>
             </a:avLst>
           </a:prstGeom>
           <a:solidFill>
@@ -6027,8 +6027,8 @@
         </p:nvSpPr>
         <p:spPr>
           <a:xfrm>
-            <a:off x="6306160" y="1892808"/>
-            <a:ext cx="2430704" cy="316611"/>
+            <a:off x="6306160" y="1911096"/>
+            <a:ext cx="2430704" cy="324612"/>
           </a:xfrm>
           <a:prstGeom prst="rect">
             <a:avLst/>
@@ -6044,14 +6044,14 @@
               <a:buNone/>
             </a:pPr>
             <a:r>
-              <a:rPr lang="en-US" sz="875" b="1" dirty="0">
+              <a:rPr lang="en-US" sz="900" b="1" dirty="0">
                 <a:solidFill>
                   <a:schemeClr val="accent1"/>
                 </a:solidFill>
               </a:rPr>
               <a:t>Deficiencia en la hora del sistema y la herramienta de Monitoreo</a:t>
             </a:r>
-            <a:endParaRPr lang="en-US" sz="875" dirty="0"/>
+            <a:endParaRPr lang="en-US" sz="900" dirty="0"/>
           </a:p>
         </p:txBody>
       </p:sp>
@@ -6063,8 +6063,8 @@
         </p:nvSpPr>
         <p:spPr>
           <a:xfrm>
-            <a:off x="6306160" y="2282571"/>
-            <a:ext cx="2430704" cy="1172101"/>
+            <a:off x="6306160" y="2308860"/>
+            <a:ext cx="2430704" cy="1240299"/>
           </a:xfrm>
           <a:prstGeom prst="rect">
             <a:avLst/>
@@ -6080,7 +6080,7 @@
               <a:buNone/>
             </a:pPr>
             <a:r>
-              <a:rPr lang="en-US" sz="775" b="1" dirty="0">
+              <a:rPr lang="en-US" sz="800" b="1" dirty="0">
                 <a:solidFill>
                   <a:schemeClr val="accent5"/>
                 </a:solidFill>
@@ -6091,14 +6091,14 @@
               <a:buNone/>
             </a:pPr>
             <a:r>
-              <a:rPr lang="en-US" sz="775" dirty="0">
+              <a:rPr lang="en-US" sz="800" dirty="0">
                 <a:solidFill>
                   <a:schemeClr val="tx1"/>
                 </a:solidFill>
               </a:rPr>
               <a:t>Descargo correos de gestión Pendiente</a:t>
             </a:r>
-            <a:endParaRPr lang="en-US" sz="775" dirty="0"/>
+            <a:endParaRPr lang="en-US" sz="800" dirty="0"/>
           </a:p>
         </p:txBody>
       </p:sp>
@@ -6111,11 +6111,11 @@
         <p:spPr>
           <a:xfrm>
             <a:off x="9011183" y="1234440"/>
-            <a:ext cx="2723312" cy="2275096"/>
+            <a:ext cx="2723312" cy="2406159"/>
           </a:xfrm>
           <a:prstGeom prst="roundRect">
             <a:avLst>
-              <a:gd name="adj" fmla="val 4019"/>
+              <a:gd name="adj" fmla="val 3800"/>
             </a:avLst>
           </a:prstGeom>
           <a:solidFill>
@@ -6255,8 +6255,8 @@
         </p:nvSpPr>
         <p:spPr>
           <a:xfrm>
-            <a:off x="9157487" y="1892808"/>
-            <a:ext cx="2430704" cy="176594"/>
+            <a:off x="9157487" y="1911096"/>
+            <a:ext cx="2430704" cy="180594"/>
           </a:xfrm>
           <a:prstGeom prst="rect">
             <a:avLst/>
@@ -6272,14 +6272,14 @@
               <a:buNone/>
             </a:pPr>
             <a:r>
-              <a:rPr lang="en-US" sz="875" b="1" dirty="0">
+              <a:rPr lang="en-US" sz="900" b="1" dirty="0">
                 <a:solidFill>
                   <a:schemeClr val="accent1"/>
                 </a:solidFill>
               </a:rPr>
               <a:t>Verificación de las condiciones en ACRM</a:t>
             </a:r>
-            <a:endParaRPr lang="en-US" sz="875" dirty="0"/>
+            <a:endParaRPr lang="en-US" sz="900" dirty="0"/>
           </a:p>
         </p:txBody>
       </p:sp>
@@ -6291,8 +6291,8 @@
         </p:nvSpPr>
         <p:spPr>
           <a:xfrm>
-            <a:off x="9157487" y="2142554"/>
-            <a:ext cx="2430704" cy="1312118"/>
+            <a:off x="9157487" y="2164842"/>
+            <a:ext cx="2430704" cy="1384317"/>
           </a:xfrm>
           <a:prstGeom prst="rect">
             <a:avLst/>
@@ -6308,7 +6308,7 @@
               <a:buNone/>
             </a:pPr>
             <a:r>
-              <a:rPr lang="en-US" sz="775" b="1" dirty="0">
+              <a:rPr lang="en-US" sz="800" b="1" dirty="0">
                 <a:solidFill>
                   <a:schemeClr val="accent5"/>
                 </a:solidFill>
@@ -6319,14 +6319,14 @@
               <a:buNone/>
             </a:pPr>
             <a:r>
-              <a:rPr lang="en-US" sz="775" b="1" dirty="0">
+              <a:rPr lang="en-US" sz="800" b="1" dirty="0">
                 <a:solidFill>
                   <a:schemeClr val="accent6"/>
                 </a:solidFill>
               </a:rPr>
               <a:t>Pendiente</a:t>
             </a:r>
-            <a:endParaRPr lang="en-US" sz="775" dirty="0"/>
+            <a:endParaRPr lang="en-US" sz="800" dirty="0"/>
           </a:p>
         </p:txBody>
       </p:sp>
@@ -6338,12 +6338,12 @@
         </p:nvSpPr>
         <p:spPr>
           <a:xfrm>
-            <a:off x="457200" y="3637552"/>
-            <a:ext cx="2723312" cy="2763248"/>
+            <a:off x="457200" y="3768615"/>
+            <a:ext cx="2723312" cy="2632185"/>
           </a:xfrm>
           <a:prstGeom prst="roundRect">
             <a:avLst>
-              <a:gd name="adj" fmla="val 3358"/>
+              <a:gd name="adj" fmla="val 3474"/>
             </a:avLst>
           </a:prstGeom>
           <a:solidFill>
@@ -6367,7 +6367,7 @@
         </p:nvSpPr>
         <p:spPr>
           <a:xfrm>
-            <a:off x="566928" y="3747280"/>
+            <a:off x="566928" y="3878343"/>
             <a:ext cx="457200" cy="457200"/>
           </a:xfrm>
           <a:prstGeom prst="ellipse">
@@ -6394,7 +6394,7 @@
         </p:nvSpPr>
         <p:spPr>
           <a:xfrm>
-            <a:off x="566928" y="3747280"/>
+            <a:off x="566928" y="3878343"/>
             <a:ext cx="457200" cy="457200"/>
           </a:xfrm>
           <a:prstGeom prst="rect">
@@ -6433,7 +6433,7 @@
         </p:nvSpPr>
         <p:spPr>
           <a:xfrm>
-            <a:off x="1115568" y="3710704"/>
+            <a:off x="1115568" y="3841767"/>
             <a:ext cx="1955216" cy="512064"/>
           </a:xfrm>
           <a:prstGeom prst="rect">
@@ -6497,8 +6497,8 @@
         </p:nvSpPr>
         <p:spPr>
           <a:xfrm>
-            <a:off x="603504" y="4295920"/>
-            <a:ext cx="2430704" cy="456629"/>
+            <a:off x="603504" y="4445271"/>
+            <a:ext cx="2430704" cy="324612"/>
           </a:xfrm>
           <a:prstGeom prst="rect">
             <a:avLst/>
@@ -6514,14 +6514,14 @@
               <a:buNone/>
             </a:pPr>
             <a:r>
-              <a:rPr lang="en-US" sz="875" b="1" dirty="0">
+              <a:rPr lang="en-US" sz="900" b="1" dirty="0">
                 <a:solidFill>
                   <a:schemeClr val="accent1"/>
                 </a:solidFill>
               </a:rPr>
               <a:t>Limitante de Accesos a los Datos de COMEDICA, alojada en la Herramienta de Monitoreo.</a:t>
             </a:r>
-            <a:endParaRPr lang="en-US" sz="875" dirty="0"/>
+            <a:endParaRPr lang="en-US" sz="900" dirty="0"/>
           </a:p>
         </p:txBody>
       </p:sp>
@@ -6533,8 +6533,8 @@
         </p:nvSpPr>
         <p:spPr>
           <a:xfrm>
-            <a:off x="603504" y="4825700"/>
-            <a:ext cx="2430704" cy="1520236"/>
+            <a:off x="603504" y="4843035"/>
+            <a:ext cx="2430704" cy="1466325"/>
           </a:xfrm>
           <a:prstGeom prst="rect">
             <a:avLst/>
@@ -6550,7 +6550,7 @@
               <a:buNone/>
             </a:pPr>
             <a:r>
-              <a:rPr lang="en-US" sz="775" b="1" dirty="0">
+              <a:rPr lang="en-US" sz="800" b="1" dirty="0">
                 <a:solidFill>
                   <a:schemeClr val="accent5"/>
                 </a:solidFill>
@@ -6561,14 +6561,14 @@
               <a:buNone/>
             </a:pPr>
             <a:r>
-              <a:rPr lang="en-US" sz="775" b="1" dirty="0">
+              <a:rPr lang="en-US" sz="800" b="1" dirty="0">
                 <a:solidFill>
                   <a:schemeClr val="accent6"/>
                 </a:solidFill>
               </a:rPr>
               <a:t>Pendiente</a:t>
             </a:r>
-            <a:endParaRPr lang="en-US" sz="775" dirty="0"/>
+            <a:endParaRPr lang="en-US" sz="800" dirty="0"/>
           </a:p>
         </p:txBody>
       </p:sp>
@@ -6580,12 +6580,12 @@
         </p:nvSpPr>
         <p:spPr>
           <a:xfrm>
-            <a:off x="3308528" y="3637552"/>
-            <a:ext cx="2723312" cy="2763248"/>
+            <a:off x="3308528" y="3768615"/>
+            <a:ext cx="2723312" cy="2632185"/>
           </a:xfrm>
           <a:prstGeom prst="roundRect">
             <a:avLst>
-              <a:gd name="adj" fmla="val 3358"/>
+              <a:gd name="adj" fmla="val 3474"/>
             </a:avLst>
           </a:prstGeom>
           <a:solidFill>
@@ -6609,7 +6609,7 @@
         </p:nvSpPr>
         <p:spPr>
           <a:xfrm>
-            <a:off x="3418256" y="3747280"/>
+            <a:off x="3418256" y="3878343"/>
             <a:ext cx="457200" cy="457200"/>
           </a:xfrm>
           <a:prstGeom prst="ellipse">
@@ -6636,7 +6636,7 @@
         </p:nvSpPr>
         <p:spPr>
           <a:xfrm>
-            <a:off x="3418256" y="3747280"/>
+            <a:off x="3418256" y="3878343"/>
             <a:ext cx="457200" cy="457200"/>
           </a:xfrm>
           <a:prstGeom prst="rect">
@@ -6675,7 +6675,7 @@
         </p:nvSpPr>
         <p:spPr>
           <a:xfrm>
-            <a:off x="3966896" y="3710704"/>
+            <a:off x="3966896" y="3841767"/>
             <a:ext cx="1955216" cy="512064"/>
           </a:xfrm>
           <a:prstGeom prst="rect">
@@ -6739,8 +6739,8 @@
         </p:nvSpPr>
         <p:spPr>
           <a:xfrm>
-            <a:off x="3454832" y="4295920"/>
-            <a:ext cx="2430704" cy="316611"/>
+            <a:off x="3454832" y="4445271"/>
+            <a:ext cx="2430704" cy="324612"/>
           </a:xfrm>
           <a:prstGeom prst="rect">
             <a:avLst/>
@@ -6756,14 +6756,14 @@
               <a:buNone/>
             </a:pPr>
             <a:r>
-              <a:rPr lang="en-US" sz="875" b="1" dirty="0">
+              <a:rPr lang="en-US" sz="900" b="1" dirty="0">
                 <a:solidFill>
                   <a:schemeClr val="accent1"/>
                 </a:solidFill>
               </a:rPr>
               <a:t>Limitante para identificar la base de datos de CRM</a:t>
             </a:r>
-            <a:endParaRPr lang="en-US" sz="875" dirty="0"/>
+            <a:endParaRPr lang="en-US" sz="900" dirty="0"/>
           </a:p>
         </p:txBody>
       </p:sp>
@@ -6775,8 +6775,8 @@
         </p:nvSpPr>
         <p:spPr>
           <a:xfrm>
-            <a:off x="3454832" y="4685683"/>
-            <a:ext cx="2430704" cy="1660253"/>
+            <a:off x="3454832" y="4843035"/>
+            <a:ext cx="2430704" cy="1466325"/>
           </a:xfrm>
           <a:prstGeom prst="rect">
             <a:avLst/>
@@ -6792,7 +6792,7 @@
               <a:buNone/>
             </a:pPr>
             <a:r>
-              <a:rPr lang="en-US" sz="775" b="1" dirty="0">
+              <a:rPr lang="en-US" sz="800" b="1" dirty="0">
                 <a:solidFill>
                   <a:schemeClr val="accent5"/>
                 </a:solidFill>
@@ -6803,14 +6803,14 @@
               <a:buNone/>
             </a:pPr>
             <a:r>
-              <a:rPr lang="en-US" sz="775" b="1" dirty="0">
+              <a:rPr lang="en-US" sz="800" b="1" dirty="0">
                 <a:solidFill>
                   <a:schemeClr val="accent6"/>
                 </a:solidFill>
               </a:rPr>
               <a:t>Pendiente</a:t>
             </a:r>
-            <a:endParaRPr lang="en-US" sz="775" dirty="0"/>
+            <a:endParaRPr lang="en-US" sz="800" dirty="0"/>
           </a:p>
         </p:txBody>
       </p:sp>
@@ -6822,12 +6822,12 @@
         </p:nvSpPr>
         <p:spPr>
           <a:xfrm>
-            <a:off x="6159856" y="3637552"/>
-            <a:ext cx="2723312" cy="2763248"/>
+            <a:off x="6159856" y="3768615"/>
+            <a:ext cx="2723312" cy="2632185"/>
           </a:xfrm>
           <a:prstGeom prst="roundRect">
             <a:avLst>
-              <a:gd name="adj" fmla="val 3358"/>
+              <a:gd name="adj" fmla="val 3474"/>
             </a:avLst>
           </a:prstGeom>
           <a:solidFill>
@@ -6851,7 +6851,7 @@
         </p:nvSpPr>
         <p:spPr>
           <a:xfrm>
-            <a:off x="6269584" y="3747280"/>
+            <a:off x="6269584" y="3878343"/>
             <a:ext cx="457200" cy="457200"/>
           </a:xfrm>
           <a:prstGeom prst="ellipse">
@@ -6878,7 +6878,7 @@
         </p:nvSpPr>
         <p:spPr>
           <a:xfrm>
-            <a:off x="6269584" y="3747280"/>
+            <a:off x="6269584" y="3878343"/>
             <a:ext cx="457200" cy="457200"/>
           </a:xfrm>
           <a:prstGeom prst="rect">
@@ -6917,7 +6917,7 @@
         </p:nvSpPr>
         <p:spPr>
           <a:xfrm>
-            <a:off x="6818224" y="3710704"/>
+            <a:off x="6818224" y="3841767"/>
             <a:ext cx="1955216" cy="512064"/>
           </a:xfrm>
           <a:prstGeom prst="rect">
@@ -6981,8 +6981,8 @@
         </p:nvSpPr>
         <p:spPr>
           <a:xfrm>
-            <a:off x="6306160" y="4295920"/>
-            <a:ext cx="2430704" cy="596646"/>
+            <a:off x="6306160" y="4445271"/>
+            <a:ext cx="2430704" cy="612648"/>
           </a:xfrm>
           <a:prstGeom prst="rect">
             <a:avLst/>
@@ -6998,14 +6998,14 @@
               <a:buNone/>
             </a:pPr>
             <a:r>
-              <a:rPr lang="en-US" sz="875" b="1" dirty="0">
+              <a:rPr lang="en-US" sz="900" b="1" dirty="0">
                 <a:solidFill>
                   <a:schemeClr val="accent1"/>
                 </a:solidFill>
               </a:rPr>
               <a:t>Falta de documentación que dé cumplimiento a lo requerido por el artículo 22 de la NRP-23 correspondiente a la adquisición del sistema CRM.</a:t>
             </a:r>
-            <a:endParaRPr lang="en-US" sz="875" dirty="0"/>
+            <a:endParaRPr lang="en-US" sz="900" dirty="0"/>
           </a:p>
         </p:txBody>
       </p:sp>
@@ -7017,8 +7017,8 @@
         </p:nvSpPr>
         <p:spPr>
           <a:xfrm>
-            <a:off x="6306160" y="4965718"/>
-            <a:ext cx="2430704" cy="1380218"/>
+            <a:off x="6306160" y="5131071"/>
+            <a:ext cx="2430704" cy="1178289"/>
           </a:xfrm>
           <a:prstGeom prst="rect">
             <a:avLst/>
@@ -7034,7 +7034,7 @@
               <a:buNone/>
             </a:pPr>
             <a:r>
-              <a:rPr lang="en-US" sz="775" b="1" dirty="0">
+              <a:rPr lang="en-US" sz="800" b="1" dirty="0">
                 <a:solidFill>
                   <a:schemeClr val="accent5"/>
                 </a:solidFill>
@@ -7045,14 +7045,14 @@
               <a:buNone/>
             </a:pPr>
             <a:r>
-              <a:rPr lang="en-US" sz="775" b="1" dirty="0">
+              <a:rPr lang="en-US" sz="800" b="1" dirty="0">
                 <a:solidFill>
                   <a:schemeClr val="accent6"/>
                 </a:solidFill>
               </a:rPr>
               <a:t>Pendiente</a:t>
             </a:r>
-            <a:endParaRPr lang="en-US" sz="775" dirty="0"/>
+            <a:endParaRPr lang="en-US" sz="800" dirty="0"/>
           </a:p>
         </p:txBody>
       </p:sp>
@@ -7064,12 +7064,12 @@
         </p:nvSpPr>
         <p:spPr>
           <a:xfrm>
-            <a:off x="9011183" y="3637552"/>
-            <a:ext cx="2723312" cy="2763248"/>
+            <a:off x="9011183" y="3768615"/>
+            <a:ext cx="2723312" cy="2632185"/>
           </a:xfrm>
           <a:prstGeom prst="roundRect">
             <a:avLst>
-              <a:gd name="adj" fmla="val 3358"/>
+              <a:gd name="adj" fmla="val 3474"/>
             </a:avLst>
           </a:prstGeom>
           <a:solidFill>
@@ -7093,7 +7093,7 @@
         </p:nvSpPr>
         <p:spPr>
           <a:xfrm>
-            <a:off x="9120911" y="3747280"/>
+            <a:off x="9120911" y="3878343"/>
             <a:ext cx="457200" cy="457200"/>
           </a:xfrm>
           <a:prstGeom prst="ellipse">
@@ -7120,7 +7120,7 @@
         </p:nvSpPr>
         <p:spPr>
           <a:xfrm>
-            <a:off x="9120911" y="3747280"/>
+            <a:off x="9120911" y="3878343"/>
             <a:ext cx="457200" cy="457200"/>
           </a:xfrm>
           <a:prstGeom prst="rect">
@@ -7159,7 +7159,7 @@
         </p:nvSpPr>
         <p:spPr>
           <a:xfrm>
-            <a:off x="9669551" y="3710704"/>
+            <a:off x="9669551" y="3841767"/>
             <a:ext cx="1955216" cy="512064"/>
           </a:xfrm>
           <a:prstGeom prst="rect">
@@ -7209,8 +7209,8 @@
         </p:nvSpPr>
         <p:spPr>
           <a:xfrm>
-            <a:off x="9157487" y="4295920"/>
-            <a:ext cx="2430704" cy="176594"/>
+            <a:off x="9157487" y="4445271"/>
+            <a:ext cx="2430704" cy="180594"/>
           </a:xfrm>
           <a:prstGeom prst="rect">
             <a:avLst/>
@@ -7226,14 +7226,14 @@
               <a:buNone/>
             </a:pPr>
             <a:r>
-              <a:rPr lang="en-US" sz="875" b="1" dirty="0">
+              <a:rPr lang="en-US" sz="900" b="1" dirty="0">
                 <a:solidFill>
                   <a:schemeClr val="accent1"/>
                 </a:solidFill>
               </a:rPr>
               <a:t>Servicios tercerizados</a:t>
             </a:r>
-            <a:endParaRPr lang="en-US" sz="875" dirty="0"/>
+            <a:endParaRPr lang="en-US" sz="900" dirty="0"/>
           </a:p>
         </p:txBody>
       </p:sp>
@@ -7245,8 +7245,8 @@
         </p:nvSpPr>
         <p:spPr>
           <a:xfrm>
-            <a:off x="9157487" y="4545665"/>
-            <a:ext cx="2430704" cy="1800271"/>
+            <a:off x="9157487" y="4699017"/>
+            <a:ext cx="2430704" cy="1610343"/>
           </a:xfrm>
           <a:prstGeom prst="rect">
             <a:avLst/>
@@ -7262,7 +7262,7 @@
               <a:buNone/>
             </a:pPr>
             <a:r>
-              <a:rPr lang="en-US" sz="775" b="1" dirty="0">
+              <a:rPr lang="en-US" sz="800" b="1" dirty="0">
                 <a:solidFill>
                   <a:schemeClr val="accent5"/>
                 </a:solidFill>
@@ -7273,14 +7273,14 @@
               <a:buNone/>
             </a:pPr>
             <a:r>
-              <a:rPr lang="en-US" sz="775" dirty="0">
+              <a:rPr lang="en-US" sz="800" dirty="0">
                 <a:solidFill>
                   <a:schemeClr val="tx1"/>
                 </a:solidFill>
               </a:rPr>
               <a:t>Como parte del fortalecimiento de los controles de seguridad asociados al servicio tercerizado del módulo ACRM, la Unidad de Seguridad de la Información y Ciberseguridad realizará una reevaluación de los riesgos de seguridad de la información y ciberseguridad, mediante la actualización de la matriz de riesgos y la revisión de los controles existentes, con el propósito de identificar oportunidades de mejora y definir las medidas adicionales de tratamiento que correspondan, en coordinación con el área responsable de la solución el proveedor. Fecha de cumplimiento: 30 de noviembre de 2026.</a:t>
             </a:r>
-            <a:endParaRPr lang="en-US" sz="775" dirty="0"/>
+            <a:endParaRPr lang="en-US" sz="800" dirty="0"/>
           </a:p>
         </p:txBody>
       </p:sp>
@@ -7462,11 +7462,11 @@
         <p:spPr>
           <a:xfrm>
             <a:off x="457200" y="1234440"/>
-            <a:ext cx="3673754" cy="3291674"/>
+            <a:ext cx="3673754" cy="3208007"/>
           </a:xfrm>
           <a:prstGeom prst="roundRect">
             <a:avLst>
-              <a:gd name="adj" fmla="val 2778"/>
+              <a:gd name="adj" fmla="val 2850"/>
             </a:avLst>
           </a:prstGeom>
           <a:solidFill>
@@ -7623,7 +7623,7 @@
         <p:spPr>
           <a:xfrm>
             <a:off x="594360" y="1655064"/>
-            <a:ext cx="3399434" cy="984352"/>
+            <a:ext cx="3399434" cy="887425"/>
           </a:xfrm>
           <a:prstGeom prst="rect">
             <a:avLst/>
@@ -7639,136 +7639,136 @@
               <a:buNone/>
             </a:pPr>
             <a:r>
+              <a:rPr lang="en-US" sz="950" b="1" dirty="0">
+                <a:solidFill>
+                  <a:schemeClr val="accent1"/>
+                </a:solidFill>
+              </a:rPr>
+              <a:t>Observación 2: Falta de eficacia en la subsanación de observaciones determinadas por el Departamento de Auditoría Interna.</a:t>
+            </a:r>
+            <a:endParaRPr lang="en-US" sz="1200" dirty="0"/>
+          </a:p>
+          <a:p>
+            <a:pPr algn="just" indent="0" marL="0">
+              <a:buNone/>
+            </a:pPr>
+            <a:r>
+              <a:rPr lang="en-US" sz="850" dirty="0">
+                <a:solidFill>
+                  <a:schemeClr val="tx1"/>
+                </a:solidFill>
+              </a:rPr>
+              <a:t>Seguimiento realizado en la presente visita de supervisión:</a:t>
+            </a:r>
+            <a:endParaRPr lang="en-US" sz="1200" dirty="0"/>
+          </a:p>
+          <a:p>
+            <a:pPr algn="just" indent="0" marL="0">
+              <a:buNone/>
+            </a:pPr>
+            <a:r>
+              <a:rPr lang="en-US" sz="850" dirty="0">
+                <a:solidFill>
+                  <a:schemeClr val="tx1"/>
+                </a:solidFill>
+              </a:rPr>
+              <a:t>Comentarios COMEDICA: en el Plan de Auditoría interna 2026 se incluyó seguimientos trimestrales como actividad 44 para solventar la observación.</a:t>
+            </a:r>
+            <a:endParaRPr lang="en-US" sz="1200" dirty="0"/>
+          </a:p>
+        </p:txBody>
+      </p:sp>
+      <p:sp>
+        <p:nvSpPr>
+          <p:cNvPr id="11" name="Com 0"/>
+          <p:cNvSpPr txBox="1"/>
+          <p:nvPr/>
+        </p:nvSpPr>
+        <p:spPr>
+          <a:xfrm>
+            <a:off x="594360" y="2597353"/>
+            <a:ext cx="3399434" cy="1515910"/>
+          </a:xfrm>
+          <a:prstGeom prst="rect">
+            <a:avLst/>
+          </a:prstGeom>
+          <a:noFill/>
+          <a:ln/>
+        </p:spPr>
+        <p:txBody>
+          <a:bodyPr wrap="square" lIns="0" tIns="0" rIns="0" bIns="0" rtlCol="0" anchor="t"/>
+          <a:lstStyle/>
+          <a:p>
+            <a:pPr algn="just" indent="0" marL="0">
+              <a:buNone/>
+            </a:pPr>
+            <a:r>
+              <a:rPr lang="en-US" sz="850" b="1" dirty="0">
+                <a:solidFill>
+                  <a:schemeClr val="accent5"/>
+                </a:solidFill>
+              </a:rPr>
+              <a:t>Comentarios  </a:t>
+            </a:r>
+            <a:pPr algn="just" indent="0" marL="0">
+              <a:buNone/>
+            </a:pPr>
+            <a:r>
+              <a:rPr lang="en-US" sz="850" dirty="0">
+                <a:solidFill>
+                  <a:schemeClr val="tx1"/>
+                </a:solidFill>
+              </a:rPr>
+              <a:t>AI 28 2024 y AI 45 2024 Otorgamiento de Préstamos. Se realizó el seguimiento correspondiente a los informes AI 44-2025, AI 64-2025 y AI 20-2026. Como resultado, las observaciones quedaron solventadas. (Se anexan los informes). AI 21 2024 y AI 26 2024 Otorgamiento de Tarjeta de Crédito. Se realizó el seguimiento correspondiente en los informes AI 14 2025 y AI 69 2025. Como resultado, las observaciones quedaron solventadas. (Se anexan los informes). Informes AI 32 2024; AI 37 2024 y AI 52 2024. Se continuará con el seguimiento, solicitando nuevamente planes de acción con fechas plazo, a cada unidad responsable. Plazo: 30/11/2026</a:t>
+            </a:r>
+            <a:endParaRPr lang="en-US" sz="850" dirty="0"/>
+          </a:p>
+        </p:txBody>
+      </p:sp>
+      <p:sp>
+        <p:nvSpPr>
+          <p:cNvPr id="12" name="Resp 0"/>
+          <p:cNvSpPr txBox="1"/>
+          <p:nvPr/>
+        </p:nvSpPr>
+        <p:spPr>
+          <a:xfrm>
+            <a:off x="594360" y="4149839"/>
+            <a:ext cx="3399434" cy="219456"/>
+          </a:xfrm>
+          <a:prstGeom prst="rect">
+            <a:avLst/>
+          </a:prstGeom>
+          <a:noFill/>
+          <a:ln/>
+        </p:spPr>
+        <p:txBody>
+          <a:bodyPr wrap="square" lIns="0" tIns="0" rIns="0" bIns="0" rtlCol="0" anchor="ctr"/>
+          <a:lstStyle/>
+          <a:p>
+            <a:pPr indent="0" marL="0">
+              <a:buNone/>
+            </a:pPr>
+            <a:r>
               <a:rPr lang="en-US" sz="900" b="1" dirty="0">
                 <a:solidFill>
+                  <a:schemeClr val="accent5"/>
+                </a:solidFill>
+              </a:rPr>
+              <a:t>Responsable  </a:t>
+            </a:r>
+            <a:pPr indent="0" marL="0">
+              <a:buNone/>
+            </a:pPr>
+            <a:r>
+              <a:rPr lang="en-US" sz="900" b="1" dirty="0">
+                <a:solidFill>
                   <a:schemeClr val="accent1"/>
                 </a:solidFill>
               </a:rPr>
-              <a:t>Observación 2: Falta de eficacia en la subsanación de observaciones determinadas por el Departamento de Auditoría Interna.</a:t>
-            </a:r>
-            <a:endParaRPr lang="en-US" sz="1200" dirty="0"/>
-          </a:p>
-          <a:p>
-            <a:pPr algn="just" indent="0" marL="0">
-              <a:buNone/>
-            </a:pPr>
-            <a:r>
-              <a:rPr lang="en-US" sz="800" dirty="0">
-                <a:solidFill>
-                  <a:schemeClr val="tx1"/>
-                </a:solidFill>
-              </a:rPr>
-              <a:t>Seguimiento realizado en la presente visita de supervisión:</a:t>
-            </a:r>
-            <a:endParaRPr lang="en-US" sz="1200" dirty="0"/>
-          </a:p>
-          <a:p>
-            <a:pPr algn="just" indent="0" marL="0">
-              <a:buNone/>
-            </a:pPr>
-            <a:r>
-              <a:rPr lang="en-US" sz="800" dirty="0">
-                <a:solidFill>
-                  <a:schemeClr val="tx1"/>
-                </a:solidFill>
-              </a:rPr>
-              <a:t>Comentarios COMEDICA: en el Plan de Auditoría interna 2026 se incluyó seguimientos trimestrales como actividad 44 para solventar la observación.</a:t>
-            </a:r>
-            <a:endParaRPr lang="en-US" sz="1200" dirty="0"/>
-          </a:p>
-        </p:txBody>
-      </p:sp>
-      <p:sp>
-        <p:nvSpPr>
-          <p:cNvPr id="11" name="Com 0"/>
-          <p:cNvSpPr txBox="1"/>
-          <p:nvPr/>
-        </p:nvSpPr>
-        <p:spPr>
-          <a:xfrm>
-            <a:off x="594360" y="2694280"/>
-            <a:ext cx="3399434" cy="1502650"/>
-          </a:xfrm>
-          <a:prstGeom prst="rect">
-            <a:avLst/>
-          </a:prstGeom>
-          <a:noFill/>
-          <a:ln/>
-        </p:spPr>
-        <p:txBody>
-          <a:bodyPr wrap="square" lIns="0" tIns="0" rIns="0" bIns="0" rtlCol="0" anchor="t"/>
-          <a:lstStyle/>
-          <a:p>
-            <a:pPr algn="just" indent="0" marL="0">
-              <a:buNone/>
-            </a:pPr>
-            <a:r>
-              <a:rPr lang="en-US" sz="800" b="1" dirty="0">
-                <a:solidFill>
-                  <a:schemeClr val="accent5"/>
-                </a:solidFill>
-              </a:rPr>
-              <a:t>Comentarios  </a:t>
-            </a:r>
-            <a:pPr algn="just" indent="0" marL="0">
-              <a:buNone/>
-            </a:pPr>
-            <a:r>
-              <a:rPr lang="en-US" sz="800" dirty="0">
-                <a:solidFill>
-                  <a:schemeClr val="tx1"/>
-                </a:solidFill>
-              </a:rPr>
-              <a:t>AI 28 2024 y AI 45 2024 Otorgamiento de Préstamos. Se realizó el seguimiento correspondiente a los informes AI 44-2025, AI 64-2025 y AI 20-2026. Como resultado, las observaciones quedaron solventadas. (Se anexan los informes). AI 21 2024 y AI 26 2024 Otorgamiento de Tarjeta de Crédito. Se realizó el seguimiento correspondiente en los informes AI 14 2025 y AI 69 2025. Como resultado, las observaciones quedaron solventadas. (Se anexan los informes). Informes AI 32 2024; AI 37 2024 y AI 52 2024. Se continuará con el seguimiento, solicitando nuevamente planes de acción con fechas plazo, a cada unidad responsable. Plazo: 30/11/2026</a:t>
-            </a:r>
-            <a:endParaRPr lang="en-US" sz="800" dirty="0"/>
-          </a:p>
-        </p:txBody>
-      </p:sp>
-      <p:sp>
-        <p:nvSpPr>
-          <p:cNvPr id="12" name="Resp 0"/>
-          <p:cNvSpPr txBox="1"/>
-          <p:nvPr/>
-        </p:nvSpPr>
-        <p:spPr>
-          <a:xfrm>
-            <a:off x="594360" y="4233506"/>
-            <a:ext cx="3399434" cy="219456"/>
-          </a:xfrm>
-          <a:prstGeom prst="rect">
-            <a:avLst/>
-          </a:prstGeom>
-          <a:noFill/>
-          <a:ln/>
-        </p:spPr>
-        <p:txBody>
-          <a:bodyPr wrap="square" lIns="0" tIns="0" rIns="0" bIns="0" rtlCol="0" anchor="ctr"/>
-          <a:lstStyle/>
-          <a:p>
-            <a:pPr indent="0" marL="0">
-              <a:buNone/>
-            </a:pPr>
-            <a:r>
-              <a:rPr lang="en-US" sz="850" b="1" dirty="0">
-                <a:solidFill>
-                  <a:schemeClr val="accent5"/>
-                </a:solidFill>
-              </a:rPr>
-              <a:t>Responsable  </a:t>
-            </a:r>
-            <a:pPr indent="0" marL="0">
-              <a:buNone/>
-            </a:pPr>
-            <a:r>
-              <a:rPr lang="en-US" sz="850" b="1" dirty="0">
-                <a:solidFill>
-                  <a:schemeClr val="accent1"/>
-                </a:solidFill>
-              </a:rPr>
               <a:t>Auditoría interna</a:t>
             </a:r>
-            <a:endParaRPr lang="en-US" sz="850" dirty="0"/>
+            <a:endParaRPr lang="en-US" sz="900" dirty="0"/>
           </a:p>
         </p:txBody>
       </p:sp>
@@ -7781,11 +7781,11 @@
         <p:spPr>
           <a:xfrm>
             <a:off x="4258970" y="1234440"/>
-            <a:ext cx="3673754" cy="3291674"/>
+            <a:ext cx="3673754" cy="3208007"/>
           </a:xfrm>
           <a:prstGeom prst="roundRect">
             <a:avLst>
-              <a:gd name="adj" fmla="val 2778"/>
+              <a:gd name="adj" fmla="val 2850"/>
             </a:avLst>
           </a:prstGeom>
           <a:solidFill>
@@ -7942,7 +7942,7 @@
         <p:spPr>
           <a:xfrm>
             <a:off x="4396130" y="1655064"/>
-            <a:ext cx="3399434" cy="840334"/>
+            <a:ext cx="3399434" cy="887425"/>
           </a:xfrm>
           <a:prstGeom prst="rect">
             <a:avLst/>
@@ -7958,136 +7958,136 @@
               <a:buNone/>
             </a:pPr>
             <a:r>
+              <a:rPr lang="en-US" sz="950" b="1" dirty="0">
+                <a:solidFill>
+                  <a:schemeClr val="accent1"/>
+                </a:solidFill>
+              </a:rPr>
+              <a:t>Observación 3: Seguimiento inoportuno de las observaciones por parte de Auditoría Interna.</a:t>
+            </a:r>
+            <a:endParaRPr lang="en-US" sz="1200" dirty="0"/>
+          </a:p>
+          <a:p>
+            <a:pPr algn="just" indent="0" marL="0">
+              <a:buNone/>
+            </a:pPr>
+            <a:r>
+              <a:rPr lang="en-US" sz="850" dirty="0">
+                <a:solidFill>
+                  <a:schemeClr val="tx1"/>
+                </a:solidFill>
+              </a:rPr>
+              <a:t>Seguimiento realizado en la presente visita de supervisión:</a:t>
+            </a:r>
+            <a:endParaRPr lang="en-US" sz="1200" dirty="0"/>
+          </a:p>
+          <a:p>
+            <a:pPr algn="just" indent="0" marL="0">
+              <a:buNone/>
+            </a:pPr>
+            <a:r>
+              <a:rPr lang="en-US" sz="850" dirty="0">
+                <a:solidFill>
+                  <a:schemeClr val="tx1"/>
+                </a:solidFill>
+              </a:rPr>
+              <a:t>Comentarios COMEDICA de R.L.: En el Plan de Auditoría Interna 2026 se incluyó seguimientos trimestrales como actividad 44 para solventar la observación.</a:t>
+            </a:r>
+            <a:endParaRPr lang="en-US" sz="1200" dirty="0"/>
+          </a:p>
+        </p:txBody>
+      </p:sp>
+      <p:sp>
+        <p:nvSpPr>
+          <p:cNvPr id="19" name="Com 1"/>
+          <p:cNvSpPr txBox="1"/>
+          <p:nvPr/>
+        </p:nvSpPr>
+        <p:spPr>
+          <a:xfrm>
+            <a:off x="4396130" y="2597353"/>
+            <a:ext cx="3399434" cy="1515910"/>
+          </a:xfrm>
+          <a:prstGeom prst="rect">
+            <a:avLst/>
+          </a:prstGeom>
+          <a:noFill/>
+          <a:ln/>
+        </p:spPr>
+        <p:txBody>
+          <a:bodyPr wrap="square" lIns="0" tIns="0" rIns="0" bIns="0" rtlCol="0" anchor="t"/>
+          <a:lstStyle/>
+          <a:p>
+            <a:pPr algn="just" indent="0" marL="0">
+              <a:buNone/>
+            </a:pPr>
+            <a:r>
+              <a:rPr lang="en-US" sz="850" b="1" dirty="0">
+                <a:solidFill>
+                  <a:schemeClr val="accent5"/>
+                </a:solidFill>
+              </a:rPr>
+              <a:t>Comentarios  </a:t>
+            </a:r>
+            <a:pPr algn="just" indent="0" marL="0">
+              <a:buNone/>
+            </a:pPr>
+            <a:r>
+              <a:rPr lang="en-US" sz="850" dirty="0">
+                <a:solidFill>
+                  <a:schemeClr val="tx1"/>
+                </a:solidFill>
+              </a:rPr>
+              <a:t>Para dar seguimiento a los informes se ha elaborado una matriz con las observaciones de todos los informes, la matriz es actualizada trimestralmente. Se anexa la matriz de seguimiento de informes.</a:t>
+            </a:r>
+            <a:endParaRPr lang="en-US" sz="850" dirty="0"/>
+          </a:p>
+        </p:txBody>
+      </p:sp>
+      <p:sp>
+        <p:nvSpPr>
+          <p:cNvPr id="20" name="Resp 1"/>
+          <p:cNvSpPr txBox="1"/>
+          <p:nvPr/>
+        </p:nvSpPr>
+        <p:spPr>
+          <a:xfrm>
+            <a:off x="4396130" y="4149839"/>
+            <a:ext cx="3399434" cy="219456"/>
+          </a:xfrm>
+          <a:prstGeom prst="rect">
+            <a:avLst/>
+          </a:prstGeom>
+          <a:noFill/>
+          <a:ln/>
+        </p:spPr>
+        <p:txBody>
+          <a:bodyPr wrap="square" lIns="0" tIns="0" rIns="0" bIns="0" rtlCol="0" anchor="ctr"/>
+          <a:lstStyle/>
+          <a:p>
+            <a:pPr indent="0" marL="0">
+              <a:buNone/>
+            </a:pPr>
+            <a:r>
               <a:rPr lang="en-US" sz="900" b="1" dirty="0">
                 <a:solidFill>
+                  <a:schemeClr val="accent5"/>
+                </a:solidFill>
+              </a:rPr>
+              <a:t>Responsable  </a:t>
+            </a:r>
+            <a:pPr indent="0" marL="0">
+              <a:buNone/>
+            </a:pPr>
+            <a:r>
+              <a:rPr lang="en-US" sz="900" b="1" dirty="0">
+                <a:solidFill>
                   <a:schemeClr val="accent1"/>
                 </a:solidFill>
               </a:rPr>
-              <a:t>Observación 3: Seguimiento inoportuno de las observaciones por parte de Auditoría Interna.</a:t>
-            </a:r>
-            <a:endParaRPr lang="en-US" sz="1200" dirty="0"/>
-          </a:p>
-          <a:p>
-            <a:pPr algn="just" indent="0" marL="0">
-              <a:buNone/>
-            </a:pPr>
-            <a:r>
-              <a:rPr lang="en-US" sz="800" dirty="0">
-                <a:solidFill>
-                  <a:schemeClr val="tx1"/>
-                </a:solidFill>
-              </a:rPr>
-              <a:t>Seguimiento realizado en la presente visita de supervisión:</a:t>
-            </a:r>
-            <a:endParaRPr lang="en-US" sz="1200" dirty="0"/>
-          </a:p>
-          <a:p>
-            <a:pPr algn="just" indent="0" marL="0">
-              <a:buNone/>
-            </a:pPr>
-            <a:r>
-              <a:rPr lang="en-US" sz="800" dirty="0">
-                <a:solidFill>
-                  <a:schemeClr val="tx1"/>
-                </a:solidFill>
-              </a:rPr>
-              <a:t>Comentarios COMEDICA de R.L.: En el Plan de Auditoría Interna 2026 se incluyó seguimientos trimestrales como actividad 44 para solventar la observación.</a:t>
-            </a:r>
-            <a:endParaRPr lang="en-US" sz="1200" dirty="0"/>
-          </a:p>
-        </p:txBody>
-      </p:sp>
-      <p:sp>
-        <p:nvSpPr>
-          <p:cNvPr id="19" name="Com 1"/>
-          <p:cNvSpPr txBox="1"/>
-          <p:nvPr/>
-        </p:nvSpPr>
-        <p:spPr>
-          <a:xfrm>
-            <a:off x="4396130" y="2550262"/>
-            <a:ext cx="3399434" cy="1646668"/>
-          </a:xfrm>
-          <a:prstGeom prst="rect">
-            <a:avLst/>
-          </a:prstGeom>
-          <a:noFill/>
-          <a:ln/>
-        </p:spPr>
-        <p:txBody>
-          <a:bodyPr wrap="square" lIns="0" tIns="0" rIns="0" bIns="0" rtlCol="0" anchor="t"/>
-          <a:lstStyle/>
-          <a:p>
-            <a:pPr algn="just" indent="0" marL="0">
-              <a:buNone/>
-            </a:pPr>
-            <a:r>
-              <a:rPr lang="en-US" sz="800" b="1" dirty="0">
-                <a:solidFill>
-                  <a:schemeClr val="accent5"/>
-                </a:solidFill>
-              </a:rPr>
-              <a:t>Comentarios  </a:t>
-            </a:r>
-            <a:pPr algn="just" indent="0" marL="0">
-              <a:buNone/>
-            </a:pPr>
-            <a:r>
-              <a:rPr lang="en-US" sz="800" dirty="0">
-                <a:solidFill>
-                  <a:schemeClr val="tx1"/>
-                </a:solidFill>
-              </a:rPr>
-              <a:t>Para dar seguimiento a los informes se ha elaborado una matriz con las observaciones de todos los informes, la matriz es actualizada trimestralmente. Se anexa la matriz de seguimiento de informes.</a:t>
-            </a:r>
-            <a:endParaRPr lang="en-US" sz="800" dirty="0"/>
-          </a:p>
-        </p:txBody>
-      </p:sp>
-      <p:sp>
-        <p:nvSpPr>
-          <p:cNvPr id="20" name="Resp 1"/>
-          <p:cNvSpPr txBox="1"/>
-          <p:nvPr/>
-        </p:nvSpPr>
-        <p:spPr>
-          <a:xfrm>
-            <a:off x="4396130" y="4233506"/>
-            <a:ext cx="3399434" cy="219456"/>
-          </a:xfrm>
-          <a:prstGeom prst="rect">
-            <a:avLst/>
-          </a:prstGeom>
-          <a:noFill/>
-          <a:ln/>
-        </p:spPr>
-        <p:txBody>
-          <a:bodyPr wrap="square" lIns="0" tIns="0" rIns="0" bIns="0" rtlCol="0" anchor="ctr"/>
-          <a:lstStyle/>
-          <a:p>
-            <a:pPr indent="0" marL="0">
-              <a:buNone/>
-            </a:pPr>
-            <a:r>
-              <a:rPr lang="en-US" sz="850" b="1" dirty="0">
-                <a:solidFill>
-                  <a:schemeClr val="accent5"/>
-                </a:solidFill>
-              </a:rPr>
-              <a:t>Responsable  </a:t>
-            </a:r>
-            <a:pPr indent="0" marL="0">
-              <a:buNone/>
-            </a:pPr>
-            <a:r>
-              <a:rPr lang="en-US" sz="850" b="1" dirty="0">
-                <a:solidFill>
-                  <a:schemeClr val="accent1"/>
-                </a:solidFill>
-              </a:rPr>
               <a:t>Auditoría interna</a:t>
             </a:r>
-            <a:endParaRPr lang="en-US" sz="850" dirty="0"/>
+            <a:endParaRPr lang="en-US" sz="900" dirty="0"/>
           </a:p>
         </p:txBody>
       </p:sp>
@@ -8100,11 +8100,11 @@
         <p:spPr>
           <a:xfrm>
             <a:off x="8060741" y="1234440"/>
-            <a:ext cx="3673754" cy="3291674"/>
+            <a:ext cx="3673754" cy="3208007"/>
           </a:xfrm>
           <a:prstGeom prst="roundRect">
             <a:avLst>
-              <a:gd name="adj" fmla="val 2778"/>
+              <a:gd name="adj" fmla="val 2850"/>
             </a:avLst>
           </a:prstGeom>
           <a:solidFill>
@@ -8261,7 +8261,7 @@
         <p:spPr>
           <a:xfrm>
             <a:off x="8197901" y="1655064"/>
-            <a:ext cx="3399434" cy="486918"/>
+            <a:ext cx="3399434" cy="510921"/>
           </a:xfrm>
           <a:prstGeom prst="rect">
             <a:avLst/>
@@ -8277,108 +8277,108 @@
               <a:buNone/>
             </a:pPr>
             <a:r>
+              <a:rPr lang="en-US" sz="950" b="1" dirty="0">
+                <a:solidFill>
+                  <a:schemeClr val="accent1"/>
+                </a:solidFill>
+              </a:rPr>
+              <a:t>Observación 2: Seguimiento a informes de observaciones del Comité de Auditoría y de Auditoría Interna durante el período 2023.</a:t>
+            </a:r>
+            <a:endParaRPr lang="en-US" sz="1200" dirty="0"/>
+          </a:p>
+        </p:txBody>
+      </p:sp>
+      <p:sp>
+        <p:nvSpPr>
+          <p:cNvPr id="27" name="Com 2"/>
+          <p:cNvSpPr txBox="1"/>
+          <p:nvPr/>
+        </p:nvSpPr>
+        <p:spPr>
+          <a:xfrm>
+            <a:off x="8197901" y="2220849"/>
+            <a:ext cx="3399434" cy="1892414"/>
+          </a:xfrm>
+          <a:prstGeom prst="rect">
+            <a:avLst/>
+          </a:prstGeom>
+          <a:noFill/>
+          <a:ln/>
+        </p:spPr>
+        <p:txBody>
+          <a:bodyPr wrap="square" lIns="0" tIns="0" rIns="0" bIns="0" rtlCol="0" anchor="t"/>
+          <a:lstStyle/>
+          <a:p>
+            <a:pPr algn="just" indent="0" marL="0">
+              <a:buNone/>
+            </a:pPr>
+            <a:r>
+              <a:rPr lang="en-US" sz="850" b="1" dirty="0">
+                <a:solidFill>
+                  <a:schemeClr val="accent5"/>
+                </a:solidFill>
+              </a:rPr>
+              <a:t>Comentarios  </a:t>
+            </a:r>
+            <a:pPr algn="just" indent="0" marL="0">
+              <a:buNone/>
+            </a:pPr>
+            <a:r>
+              <a:rPr lang="en-US" sz="850" dirty="0">
+                <a:solidFill>
+                  <a:schemeClr val="tx1"/>
+                </a:solidFill>
+              </a:rPr>
+              <a:t>Se realizará nuevamente el seguimiento de las observaciones pendientes de solventar en las Actas: 173 y 175; Plazo: 30/11/2026</a:t>
+            </a:r>
+            <a:endParaRPr lang="en-US" sz="850" dirty="0"/>
+          </a:p>
+        </p:txBody>
+      </p:sp>
+      <p:sp>
+        <p:nvSpPr>
+          <p:cNvPr id="28" name="Resp 2"/>
+          <p:cNvSpPr txBox="1"/>
+          <p:nvPr/>
+        </p:nvSpPr>
+        <p:spPr>
+          <a:xfrm>
+            <a:off x="8197901" y="4149839"/>
+            <a:ext cx="3399434" cy="219456"/>
+          </a:xfrm>
+          <a:prstGeom prst="rect">
+            <a:avLst/>
+          </a:prstGeom>
+          <a:noFill/>
+          <a:ln/>
+        </p:spPr>
+        <p:txBody>
+          <a:bodyPr wrap="square" lIns="0" tIns="0" rIns="0" bIns="0" rtlCol="0" anchor="ctr"/>
+          <a:lstStyle/>
+          <a:p>
+            <a:pPr indent="0" marL="0">
+              <a:buNone/>
+            </a:pPr>
+            <a:r>
               <a:rPr lang="en-US" sz="900" b="1" dirty="0">
                 <a:solidFill>
+                  <a:schemeClr val="accent5"/>
+                </a:solidFill>
+              </a:rPr>
+              <a:t>Responsable  </a:t>
+            </a:r>
+            <a:pPr indent="0" marL="0">
+              <a:buNone/>
+            </a:pPr>
+            <a:r>
+              <a:rPr lang="en-US" sz="900" b="1" dirty="0">
+                <a:solidFill>
                   <a:schemeClr val="accent1"/>
                 </a:solidFill>
               </a:rPr>
-              <a:t>Observación 2: Seguimiento a informes de observaciones del Comité de Auditoría y de Auditoría Interna durante el período 2023.</a:t>
-            </a:r>
-            <a:endParaRPr lang="en-US" sz="1200" dirty="0"/>
-          </a:p>
-        </p:txBody>
-      </p:sp>
-      <p:sp>
-        <p:nvSpPr>
-          <p:cNvPr id="27" name="Com 2"/>
-          <p:cNvSpPr txBox="1"/>
-          <p:nvPr/>
-        </p:nvSpPr>
-        <p:spPr>
-          <a:xfrm>
-            <a:off x="8197901" y="2196846"/>
-            <a:ext cx="3399434" cy="2000084"/>
-          </a:xfrm>
-          <a:prstGeom prst="rect">
-            <a:avLst/>
-          </a:prstGeom>
-          <a:noFill/>
-          <a:ln/>
-        </p:spPr>
-        <p:txBody>
-          <a:bodyPr wrap="square" lIns="0" tIns="0" rIns="0" bIns="0" rtlCol="0" anchor="t"/>
-          <a:lstStyle/>
-          <a:p>
-            <a:pPr algn="just" indent="0" marL="0">
-              <a:buNone/>
-            </a:pPr>
-            <a:r>
-              <a:rPr lang="en-US" sz="800" b="1" dirty="0">
-                <a:solidFill>
-                  <a:schemeClr val="accent5"/>
-                </a:solidFill>
-              </a:rPr>
-              <a:t>Comentarios  </a:t>
-            </a:r>
-            <a:pPr algn="just" indent="0" marL="0">
-              <a:buNone/>
-            </a:pPr>
-            <a:r>
-              <a:rPr lang="en-US" sz="800" dirty="0">
-                <a:solidFill>
-                  <a:schemeClr val="tx1"/>
-                </a:solidFill>
-              </a:rPr>
-              <a:t>Se realizará nuevamente el seguimiento de las observaciones pendientes de solventar en las Actas: 173 y 175; Plazo: 30/11/2026</a:t>
-            </a:r>
-            <a:endParaRPr lang="en-US" sz="800" dirty="0"/>
-          </a:p>
-        </p:txBody>
-      </p:sp>
-      <p:sp>
-        <p:nvSpPr>
-          <p:cNvPr id="28" name="Resp 2"/>
-          <p:cNvSpPr txBox="1"/>
-          <p:nvPr/>
-        </p:nvSpPr>
-        <p:spPr>
-          <a:xfrm>
-            <a:off x="8197901" y="4233506"/>
-            <a:ext cx="3399434" cy="219456"/>
-          </a:xfrm>
-          <a:prstGeom prst="rect">
-            <a:avLst/>
-          </a:prstGeom>
-          <a:noFill/>
-          <a:ln/>
-        </p:spPr>
-        <p:txBody>
-          <a:bodyPr wrap="square" lIns="0" tIns="0" rIns="0" bIns="0" rtlCol="0" anchor="ctr"/>
-          <a:lstStyle/>
-          <a:p>
-            <a:pPr indent="0" marL="0">
-              <a:buNone/>
-            </a:pPr>
-            <a:r>
-              <a:rPr lang="en-US" sz="850" b="1" dirty="0">
-                <a:solidFill>
-                  <a:schemeClr val="accent5"/>
-                </a:solidFill>
-              </a:rPr>
-              <a:t>Responsable  </a:t>
-            </a:r>
-            <a:pPr indent="0" marL="0">
-              <a:buNone/>
-            </a:pPr>
-            <a:r>
-              <a:rPr lang="en-US" sz="850" b="1" dirty="0">
-                <a:solidFill>
-                  <a:schemeClr val="accent1"/>
-                </a:solidFill>
-              </a:rPr>
               <a:t>Auditoría interna</a:t>
             </a:r>
-            <a:endParaRPr lang="en-US" sz="850" dirty="0"/>
+            <a:endParaRPr lang="en-US" sz="900" dirty="0"/>
           </a:p>
         </p:txBody>
       </p:sp>
@@ -8390,12 +8390,12 @@
         </p:nvSpPr>
         <p:spPr>
           <a:xfrm>
-            <a:off x="457200" y="4654130"/>
-            <a:ext cx="3673754" cy="1746670"/>
+            <a:off x="457200" y="4570463"/>
+            <a:ext cx="3673754" cy="1830337"/>
           </a:xfrm>
           <a:prstGeom prst="roundRect">
             <a:avLst>
-              <a:gd name="adj" fmla="val 5235"/>
+              <a:gd name="adj" fmla="val 4996"/>
             </a:avLst>
           </a:prstGeom>
           <a:solidFill>
@@ -8421,7 +8421,7 @@
         </p:nvSpPr>
         <p:spPr>
           <a:xfrm>
-            <a:off x="566928" y="4745570"/>
+            <a:off x="566928" y="4661903"/>
             <a:ext cx="1600200" cy="237744"/>
           </a:xfrm>
           <a:prstGeom prst="roundRect">
@@ -8450,7 +8450,7 @@
         </p:nvSpPr>
         <p:spPr>
           <a:xfrm>
-            <a:off x="566928" y="4745570"/>
+            <a:off x="566928" y="4661903"/>
             <a:ext cx="1600200" cy="237744"/>
           </a:xfrm>
           <a:prstGeom prst="rect">
@@ -8486,7 +8486,7 @@
         </p:nvSpPr>
         <p:spPr>
           <a:xfrm>
-            <a:off x="2240280" y="4745570"/>
+            <a:off x="2240280" y="4661903"/>
             <a:ext cx="1051560" cy="237744"/>
           </a:xfrm>
           <a:prstGeom prst="roundRect">
@@ -8515,7 +8515,7 @@
         </p:nvSpPr>
         <p:spPr>
           <a:xfrm>
-            <a:off x="2240280" y="4745570"/>
+            <a:off x="2240280" y="4661903"/>
             <a:ext cx="1051560" cy="237744"/>
           </a:xfrm>
           <a:prstGeom prst="rect">
@@ -8551,8 +8551,8 @@
         </p:nvSpPr>
         <p:spPr>
           <a:xfrm>
-            <a:off x="594360" y="5074754"/>
-            <a:ext cx="3399434" cy="467258"/>
+            <a:off x="594360" y="4991087"/>
+            <a:ext cx="3399434" cy="491033"/>
           </a:xfrm>
           <a:prstGeom prst="rect">
             <a:avLst/>
@@ -8568,7 +8568,7 @@
               <a:buNone/>
             </a:pPr>
             <a:r>
-              <a:rPr lang="en-US" sz="900" b="1" dirty="0">
+              <a:rPr lang="en-US" sz="950" b="1" dirty="0">
                 <a:solidFill>
                   <a:schemeClr val="accent1"/>
                 </a:solidFill>
@@ -8582,7 +8582,7 @@
               <a:buNone/>
             </a:pPr>
             <a:r>
-              <a:rPr lang="en-US" sz="800" dirty="0">
+              <a:rPr lang="en-US" sz="850" dirty="0">
                 <a:solidFill>
                   <a:schemeClr val="tx1"/>
                 </a:solidFill>
@@ -8601,8 +8601,8 @@
         </p:nvSpPr>
         <p:spPr>
           <a:xfrm>
-            <a:off x="594360" y="5596876"/>
-            <a:ext cx="3399434" cy="474740"/>
+            <a:off x="594360" y="5536984"/>
+            <a:ext cx="3399434" cy="534632"/>
           </a:xfrm>
           <a:prstGeom prst="rect">
             <a:avLst/>
@@ -8618,7 +8618,7 @@
               <a:buNone/>
             </a:pPr>
             <a:r>
-              <a:rPr lang="en-US" sz="800" b="1" dirty="0">
+              <a:rPr lang="en-US" sz="850" b="1" dirty="0">
                 <a:solidFill>
                   <a:schemeClr val="accent5"/>
                 </a:solidFill>
@@ -8629,14 +8629,14 @@
               <a:buNone/>
             </a:pPr>
             <a:r>
-              <a:rPr lang="en-US" sz="800" dirty="0">
+              <a:rPr lang="en-US" sz="850" dirty="0">
                 <a:solidFill>
                   <a:schemeClr val="tx1"/>
                 </a:solidFill>
               </a:rPr>
               <a:t>Sin comentarios ni documentación</a:t>
             </a:r>
-            <a:endParaRPr lang="en-US" sz="800" dirty="0"/>
+            <a:endParaRPr lang="en-US" sz="850" dirty="0"/>
           </a:p>
         </p:txBody>
       </p:sp>
@@ -8665,7 +8665,7 @@
               <a:buNone/>
             </a:pPr>
             <a:r>
-              <a:rPr lang="en-US" sz="850" b="1" dirty="0">
+              <a:rPr lang="en-US" sz="900" b="1" dirty="0">
                 <a:solidFill>
                   <a:schemeClr val="accent5"/>
                 </a:solidFill>
@@ -8676,14 +8676,14 @@
               <a:buNone/>
             </a:pPr>
             <a:r>
-              <a:rPr lang="en-US" sz="850" b="1" dirty="0">
+              <a:rPr lang="en-US" sz="900" b="1" dirty="0">
                 <a:solidFill>
                   <a:schemeClr val="accent1"/>
                 </a:solidFill>
               </a:rPr>
               <a:t>Gerencia de Oficialía de Cumplimiento</a:t>
             </a:r>
-            <a:endParaRPr lang="en-US" sz="850" dirty="0"/>
+            <a:endParaRPr lang="en-US" sz="900" dirty="0"/>
           </a:p>
         </p:txBody>
       </p:sp>
@@ -8695,12 +8695,12 @@
         </p:nvSpPr>
         <p:spPr>
           <a:xfrm>
-            <a:off x="4258970" y="4654130"/>
-            <a:ext cx="3673754" cy="1746670"/>
+            <a:off x="4258970" y="4570463"/>
+            <a:ext cx="3673754" cy="1830337"/>
           </a:xfrm>
           <a:prstGeom prst="roundRect">
             <a:avLst>
-              <a:gd name="adj" fmla="val 5235"/>
+              <a:gd name="adj" fmla="val 4996"/>
             </a:avLst>
           </a:prstGeom>
           <a:solidFill>
@@ -8726,7 +8726,7 @@
         </p:nvSpPr>
         <p:spPr>
           <a:xfrm>
-            <a:off x="4368698" y="4745570"/>
+            <a:off x="4368698" y="4661903"/>
             <a:ext cx="1600200" cy="237744"/>
           </a:xfrm>
           <a:prstGeom prst="roundRect">
@@ -8755,7 +8755,7 @@
         </p:nvSpPr>
         <p:spPr>
           <a:xfrm>
-            <a:off x="4368698" y="4745570"/>
+            <a:off x="4368698" y="4661903"/>
             <a:ext cx="1600200" cy="237744"/>
           </a:xfrm>
           <a:prstGeom prst="rect">
@@ -8791,7 +8791,7 @@
         </p:nvSpPr>
         <p:spPr>
           <a:xfrm>
-            <a:off x="6042050" y="4745570"/>
+            <a:off x="6042050" y="4661903"/>
             <a:ext cx="1691640" cy="237744"/>
           </a:xfrm>
           <a:prstGeom prst="roundRect">
@@ -8820,7 +8820,7 @@
         </p:nvSpPr>
         <p:spPr>
           <a:xfrm>
-            <a:off x="6042050" y="4745570"/>
+            <a:off x="6042050" y="4661903"/>
             <a:ext cx="1691640" cy="237744"/>
           </a:xfrm>
           <a:prstGeom prst="rect">
@@ -8856,8 +8856,8 @@
         </p:nvSpPr>
         <p:spPr>
           <a:xfrm>
-            <a:off x="4396130" y="5074754"/>
-            <a:ext cx="3399434" cy="467258"/>
+            <a:off x="4396130" y="4991087"/>
+            <a:ext cx="3399434" cy="491033"/>
           </a:xfrm>
           <a:prstGeom prst="rect">
             <a:avLst/>
@@ -8873,7 +8873,7 @@
               <a:buNone/>
             </a:pPr>
             <a:r>
-              <a:rPr lang="en-US" sz="900" b="1" dirty="0">
+              <a:rPr lang="en-US" sz="950" b="1" dirty="0">
                 <a:solidFill>
                   <a:schemeClr val="accent1"/>
                 </a:solidFill>
@@ -8887,7 +8887,7 @@
               <a:buNone/>
             </a:pPr>
             <a:r>
-              <a:rPr lang="en-US" sz="800" dirty="0">
+              <a:rPr lang="en-US" sz="850" dirty="0">
                 <a:solidFill>
                   <a:schemeClr val="tx1"/>
                 </a:solidFill>
@@ -8906,8 +8906,8 @@
         </p:nvSpPr>
         <p:spPr>
           <a:xfrm>
-            <a:off x="4396130" y="5596876"/>
-            <a:ext cx="3399434" cy="474740"/>
+            <a:off x="4396130" y="5536984"/>
+            <a:ext cx="3399434" cy="534632"/>
           </a:xfrm>
           <a:prstGeom prst="rect">
             <a:avLst/>
@@ -8923,7 +8923,7 @@
               <a:buNone/>
             </a:pPr>
             <a:r>
-              <a:rPr lang="en-US" sz="800" b="1" dirty="0">
+              <a:rPr lang="en-US" sz="850" b="1" dirty="0">
                 <a:solidFill>
                   <a:schemeClr val="accent5"/>
                 </a:solidFill>
@@ -8934,14 +8934,14 @@
               <a:buNone/>
             </a:pPr>
             <a:r>
-              <a:rPr lang="en-US" sz="800" dirty="0">
+              <a:rPr lang="en-US" sz="850" dirty="0">
                 <a:solidFill>
                   <a:schemeClr val="tx1"/>
                 </a:solidFill>
               </a:rPr>
               <a:t>Se gestionará con la Gerencia de Oficialía de Cumplimiento un nuevo Plan de Acción. Auditoría Interna dará seguimiento. Plazo: 30/11/2026</a:t>
             </a:r>
-            <a:endParaRPr lang="en-US" sz="800" dirty="0"/>
+            <a:endParaRPr lang="en-US" sz="850" dirty="0"/>
           </a:p>
         </p:txBody>
       </p:sp>
@@ -8970,7 +8970,7 @@
               <a:buNone/>
             </a:pPr>
             <a:r>
-              <a:rPr lang="en-US" sz="850" b="1" dirty="0">
+              <a:rPr lang="en-US" sz="900" b="1" dirty="0">
                 <a:solidFill>
                   <a:schemeClr val="accent5"/>
                 </a:solidFill>
@@ -8981,14 +8981,14 @@
               <a:buNone/>
             </a:pPr>
             <a:r>
-              <a:rPr lang="en-US" sz="850" b="1" dirty="0">
+              <a:rPr lang="en-US" sz="900" b="1" dirty="0">
                 <a:solidFill>
                   <a:schemeClr val="accent1"/>
                 </a:solidFill>
               </a:rPr>
               <a:t>Auditoría interna</a:t>
             </a:r>
-            <a:endParaRPr lang="en-US" sz="850" dirty="0"/>
+            <a:endParaRPr lang="en-US" sz="900" dirty="0"/>
           </a:p>
         </p:txBody>
       </p:sp>
@@ -9170,11 +9170,11 @@
         <p:spPr>
           <a:xfrm>
             <a:off x="457200" y="1234440"/>
-            <a:ext cx="5574640" cy="2529739"/>
+            <a:ext cx="5574640" cy="2410911"/>
           </a:xfrm>
           <a:prstGeom prst="roundRect">
             <a:avLst>
-              <a:gd name="adj" fmla="val 3615"/>
+              <a:gd name="adj" fmla="val 3793"/>
             </a:avLst>
           </a:prstGeom>
           <a:solidFill>
@@ -9381,7 +9381,7 @@
         <p:spPr>
           <a:xfrm>
             <a:off x="594360" y="2159356"/>
-            <a:ext cx="5300320" cy="1275639"/>
+            <a:ext cx="5300320" cy="1156811"/>
           </a:xfrm>
           <a:prstGeom prst="rect">
             <a:avLst/>
@@ -9427,7 +9427,7 @@
         </p:nvSpPr>
         <p:spPr>
           <a:xfrm>
-            <a:off x="594360" y="3471571"/>
+            <a:off x="594360" y="3352743"/>
             <a:ext cx="5300320" cy="219456"/>
           </a:xfrm>
           <a:prstGeom prst="rect">
@@ -9475,11 +9475,11 @@
         <p:spPr>
           <a:xfrm>
             <a:off x="6159856" y="1234440"/>
-            <a:ext cx="5574640" cy="2529739"/>
+            <a:ext cx="5574640" cy="2410911"/>
           </a:xfrm>
           <a:prstGeom prst="roundRect">
             <a:avLst>
-              <a:gd name="adj" fmla="val 3615"/>
+              <a:gd name="adj" fmla="val 3793"/>
             </a:avLst>
           </a:prstGeom>
           <a:solidFill>
@@ -9636,7 +9636,7 @@
         <p:spPr>
           <a:xfrm>
             <a:off x="6297016" y="1655064"/>
-            <a:ext cx="5300320" cy="678942"/>
+            <a:ext cx="5300320" cy="470916"/>
           </a:xfrm>
           <a:prstGeom prst="rect">
             <a:avLst/>
@@ -9671,8 +9671,8 @@
         </p:nvSpPr>
         <p:spPr>
           <a:xfrm>
-            <a:off x="6297016" y="2388870"/>
-            <a:ext cx="5300320" cy="1046125"/>
+            <a:off x="6297016" y="2180844"/>
+            <a:ext cx="5300320" cy="1135323"/>
           </a:xfrm>
           <a:prstGeom prst="rect">
             <a:avLst/>
@@ -9718,7 +9718,7 @@
         </p:nvSpPr>
         <p:spPr>
           <a:xfrm>
-            <a:off x="6297016" y="3471571"/>
+            <a:off x="6297016" y="3352743"/>
             <a:ext cx="5300320" cy="219456"/>
           </a:xfrm>
           <a:prstGeom prst="rect">
@@ -9765,12 +9765,12 @@
         </p:nvSpPr>
         <p:spPr>
           <a:xfrm>
-            <a:off x="457200" y="3892195"/>
-            <a:ext cx="5574640" cy="2508605"/>
+            <a:off x="457200" y="3773367"/>
+            <a:ext cx="5574640" cy="2627433"/>
           </a:xfrm>
           <a:prstGeom prst="roundRect">
             <a:avLst>
-              <a:gd name="adj" fmla="val 3645"/>
+              <a:gd name="adj" fmla="val 3480"/>
             </a:avLst>
           </a:prstGeom>
           <a:solidFill>
@@ -9796,7 +9796,7 @@
         </p:nvSpPr>
         <p:spPr>
           <a:xfrm>
-            <a:off x="566928" y="3983635"/>
+            <a:off x="566928" y="3864807"/>
             <a:ext cx="1600200" cy="237744"/>
           </a:xfrm>
           <a:prstGeom prst="roundRect">
@@ -9825,7 +9825,7 @@
         </p:nvSpPr>
         <p:spPr>
           <a:xfrm>
-            <a:off x="566928" y="3983635"/>
+            <a:off x="566928" y="3864807"/>
             <a:ext cx="1600200" cy="237744"/>
           </a:xfrm>
           <a:prstGeom prst="rect">
@@ -9861,7 +9861,7 @@
         </p:nvSpPr>
         <p:spPr>
           <a:xfrm>
-            <a:off x="2240280" y="3983635"/>
+            <a:off x="2240280" y="3864807"/>
             <a:ext cx="1691640" cy="237744"/>
           </a:xfrm>
           <a:prstGeom prst="roundRect">
@@ -9890,7 +9890,7 @@
         </p:nvSpPr>
         <p:spPr>
           <a:xfrm>
-            <a:off x="2240280" y="3983635"/>
+            <a:off x="2240280" y="3864807"/>
             <a:ext cx="1691640" cy="237744"/>
           </a:xfrm>
           <a:prstGeom prst="rect">
@@ -9926,7 +9926,7 @@
         </p:nvSpPr>
         <p:spPr>
           <a:xfrm>
-            <a:off x="594360" y="4312819"/>
+            <a:off x="594360" y="4193991"/>
             <a:ext cx="5300320" cy="657454"/>
           </a:xfrm>
           <a:prstGeom prst="rect">
@@ -9976,8 +9976,8 @@
         </p:nvSpPr>
         <p:spPr>
           <a:xfrm>
-            <a:off x="594360" y="5025136"/>
-            <a:ext cx="5300320" cy="1046480"/>
+            <a:off x="594360" y="4906308"/>
+            <a:ext cx="5300320" cy="1165308"/>
           </a:xfrm>
           <a:prstGeom prst="rect">
             <a:avLst/>
@@ -10070,12 +10070,12 @@
         </p:nvSpPr>
         <p:spPr>
           <a:xfrm>
-            <a:off x="6159856" y="3892195"/>
-            <a:ext cx="5574640" cy="2508605"/>
+            <a:off x="6159856" y="3773367"/>
+            <a:ext cx="5574640" cy="2627433"/>
           </a:xfrm>
           <a:prstGeom prst="roundRect">
             <a:avLst>
-              <a:gd name="adj" fmla="val 3645"/>
+              <a:gd name="adj" fmla="val 3480"/>
             </a:avLst>
           </a:prstGeom>
           <a:solidFill>
@@ -10101,7 +10101,7 @@
         </p:nvSpPr>
         <p:spPr>
           <a:xfrm>
-            <a:off x="6269584" y="3983635"/>
+            <a:off x="6269584" y="3864807"/>
             <a:ext cx="1600200" cy="237744"/>
           </a:xfrm>
           <a:prstGeom prst="roundRect">
@@ -10130,7 +10130,7 @@
         </p:nvSpPr>
         <p:spPr>
           <a:xfrm>
-            <a:off x="6269584" y="3983635"/>
+            <a:off x="6269584" y="3864807"/>
             <a:ext cx="1600200" cy="237744"/>
           </a:xfrm>
           <a:prstGeom prst="rect">
@@ -10166,7 +10166,7 @@
         </p:nvSpPr>
         <p:spPr>
           <a:xfrm>
-            <a:off x="7942936" y="3983635"/>
+            <a:off x="7942936" y="3864807"/>
             <a:ext cx="1051560" cy="237744"/>
           </a:xfrm>
           <a:prstGeom prst="roundRect">
@@ -10195,7 +10195,7 @@
         </p:nvSpPr>
         <p:spPr>
           <a:xfrm>
-            <a:off x="7942936" y="3983635"/>
+            <a:off x="7942936" y="3864807"/>
             <a:ext cx="1051560" cy="237744"/>
           </a:xfrm>
           <a:prstGeom prst="rect">
@@ -10231,7 +10231,7 @@
         </p:nvSpPr>
         <p:spPr>
           <a:xfrm>
-            <a:off x="6297016" y="4312819"/>
+            <a:off x="6297016" y="4193991"/>
             <a:ext cx="5300320" cy="678942"/>
           </a:xfrm>
           <a:prstGeom prst="rect">
@@ -10267,8 +10267,8 @@
         </p:nvSpPr>
         <p:spPr>
           <a:xfrm>
-            <a:off x="6297016" y="5046625"/>
-            <a:ext cx="5300320" cy="1024991"/>
+            <a:off x="6297016" y="4927797"/>
+            <a:ext cx="5300320" cy="1143819"/>
           </a:xfrm>
           <a:prstGeom prst="rect">
             <a:avLst/>

</xml_diff>

<commit_message>
Gestión de Riesgo 23486 slide 1: nombramiento 15527 card and resultados preliminares header
Co-Authored-By: Claude Opus 5.5 <noreply@anthropic.com>
Claude-Session: https://claude.ai/code/session_01F1WXR13Nv8neEtLhaK3ELa
</commit_message>
<xml_diff>
--- a/supervision-gobierno-corporativo/Gestion_Riesgo_Especifico_DS-SABAO-BCS-BC-23486.pptx
+++ b/supervision-gobierno-corporativo/Gestion_Riesgo_Especifico_DS-SABAO-BCS-BC-23486.pptx
@@ -294,7 +294,7 @@
           <a:p>
             <a:r>
               <a:rPr lang="en-US" dirty="0"/>
-              <a:t>Visita de supervisión ampliada: inicio 15/07/2026, acta de cierre 10/09/2026, corte 31/05/2026; resultados preliminares Circular DS-SABAO-BCS-BC-23486 del 02/10/2026. Matriz de requerimientos DS-SABAO-BCS-BC-23486. 17 observaciones nuevas (A: 2, B: 15) y 9 observaciones de visitas anteriores en seguimiento (Circulares 16572, 18445 y 29295): 5 no superadas y 4 parcialmente superadas.</a:t>
+              <a:t>Nombramiento de visita ampliada: Circular SABAO-BCS-BC-15527; inicio 15/07/2026, acta de cierre 10/09/2026, corte 31/05/2026. Resultados preliminares: Circular DS-SABAO-BCS-BC-23486 del 02/10/2026. 17 observaciones nuevas (A: 2, B: 15) y 9 observaciones de visitas anteriores en seguimiento (Circulares 16572, 18445 y 29295): 5 no superadas y 4 parcialmente superadas.</a:t>
             </a:r>
           </a:p>
         </p:txBody>
@@ -868,7 +868,7 @@
           </a:prstGeom>
           <a:extLst>
             <a:ext uri="{C572A759-6A51-4108-AA02-DFA0A04FC94B}">
-              <ma14:wrappingTextBoxFlag xmlns="" xmlns:ma14="http://schemas.microsoft.com/office/mac/drawingml/2011/main" val="0"/>
+              <ma14:wrappingTextBoxFlag xmlns:ma14="http://schemas.microsoft.com/office/mac/drawingml/2011/main" xmlns="" val="0"/>
             </a:ext>
           </a:extLst>
         </p:spPr>
@@ -982,7 +982,7 @@
           </a:prstGeom>
           <a:extLst>
             <a:ext uri="{C572A759-6A51-4108-AA02-DFA0A04FC94B}">
-              <ma14:wrappingTextBoxFlag xmlns="" xmlns:ma14="http://schemas.microsoft.com/office/mac/drawingml/2011/main" val="0"/>
+              <ma14:wrappingTextBoxFlag xmlns:ma14="http://schemas.microsoft.com/office/mac/drawingml/2011/main" xmlns="" val="0"/>
             </a:ext>
           </a:extLst>
         </p:spPr>
@@ -1057,7 +1057,7 @@
           </a:prstGeom>
           <a:extLst>
             <a:ext uri="{C572A759-6A51-4108-AA02-DFA0A04FC94B}">
-              <ma14:wrappingTextBoxFlag xmlns="" xmlns:ma14="http://schemas.microsoft.com/office/mac/drawingml/2011/main" val="0"/>
+              <ma14:wrappingTextBoxFlag xmlns:ma14="http://schemas.microsoft.com/office/mac/drawingml/2011/main" xmlns="" val="0"/>
             </a:ext>
           </a:extLst>
         </p:spPr>
@@ -1369,8 +1369,8 @@
         </p:nvSpPr>
         <p:spPr>
           <a:xfrm>
-            <a:off x="-70838" y="1304384"/>
-            <a:ext cx="2546453" cy="2858042"/>
+            <a:off x="56147" y="1304384"/>
+            <a:ext cx="2419468" cy="2462944"/>
           </a:xfrm>
           <a:prstGeom prst="rect">
             <a:avLst/>
@@ -1429,92 +1429,6 @@
               <a:t>Gestión de Riesgo Específico</a:t>
             </a:r>
           </a:p>
-          <a:p>
-            <a:pPr marL="0" indent="0" algn="ctr">
-              <a:buNone/>
-            </a:pPr>
-            <a:endParaRPr lang="es-SV" sz="2500" b="1" dirty="0">
-              <a:solidFill>
-                <a:schemeClr val="bg1"/>
-              </a:solidFill>
-              <a:latin typeface="Arial" panose="020B0604020202020204" pitchFamily="34" charset="0"/>
-              <a:ea typeface="Cambria" pitchFamily="34" charset="-122"/>
-              <a:cs typeface="Arial" panose="020B0604020202020204" pitchFamily="34" charset="0"/>
-            </a:endParaRPr>
-          </a:p>
-          <a:p>
-            <a:pPr marL="0" indent="0" algn="ctr">
-              <a:buNone/>
-            </a:pPr>
-            <a:endParaRPr lang="es-SV" sz="2500" noProof="0" dirty="0">
-              <a:solidFill>
-                <a:schemeClr val="bg1"/>
-              </a:solidFill>
-              <a:latin typeface="Arial" panose="020B0604020202020204" pitchFamily="34" charset="0"/>
-              <a:cs typeface="Arial" panose="020B0604020202020204" pitchFamily="34" charset="0"/>
-            </a:endParaRPr>
-          </a:p>
-        </p:txBody>
-      </p:sp>
-      <p:sp>
-        <p:nvSpPr>
-          <p:cNvPr id="4" name="Panel código"/>
-          <p:cNvSpPr txBox="1"/>
-          <p:nvPr/>
-        </p:nvSpPr>
-        <p:spPr>
-          <a:xfrm>
-            <a:off x="199554" y="434339"/>
-            <a:ext cx="2057400" cy="870043"/>
-          </a:xfrm>
-          <a:prstGeom prst="rect">
-            <a:avLst/>
-          </a:prstGeom>
-          <a:noFill/>
-          <a:ln/>
-        </p:spPr>
-        <p:txBody>
-          <a:bodyPr wrap="square" lIns="0" tIns="0" rIns="0" bIns="0" rtlCol="0" anchor="t"/>
-          <a:lstStyle/>
-          <a:p>
-            <a:pPr marL="0" indent="0" algn="ctr">
-              <a:buNone/>
-            </a:pPr>
-            <a:r>
-              <a:rPr lang="es-SV" sz="1400" b="1" noProof="0" dirty="0">
-                <a:solidFill>
-                  <a:schemeClr val="bg2"/>
-                </a:solidFill>
-              </a:rPr>
-              <a:t>Circular </a:t>
-            </a:r>
-          </a:p>
-          <a:p>
-            <a:pPr marL="0" indent="0" algn="ctr">
-              <a:buNone/>
-            </a:pPr>
-            <a:r>
-              <a:rPr lang="es-SV" sz="1400" b="1" noProof="0" dirty="0">
-                <a:solidFill>
-                  <a:schemeClr val="bg2"/>
-                </a:solidFill>
-              </a:rPr>
-              <a:t>DS-SABAO-BCS-BC-23486</a:t>
-            </a:r>
-          </a:p>
-          <a:p>
-            <a:pPr marL="0" indent="0" algn="ctr">
-              <a:buNone/>
-            </a:pPr>
-            <a:r>
-              <a:rPr lang="es-SV" sz="1400" b="1" dirty="0">
-                <a:solidFill>
-                  <a:schemeClr val="bg2"/>
-                </a:solidFill>
-              </a:rPr>
-              <a:t>02/10/2026</a:t>
-            </a:r>
-          </a:p>
         </p:txBody>
       </p:sp>
       <p:sp>
@@ -1583,12 +1497,11 @@
             <a:r>
               <a:rPr lang="es-SV" sz="1200" noProof="0" dirty="0">
                 <a:solidFill>
-                  <a:schemeClr val="accent5"/>
+                  <a:srgbClr val="002060"/>
                 </a:solidFill>
               </a:rPr>
               <a:t>Visita de supervisión · Gestión de Riesgo Específico</a:t>
             </a:r>
-            <a:endParaRPr lang="es-SV" sz="1200" noProof="0" dirty="0"/>
           </a:p>
         </p:txBody>
       </p:sp>
@@ -1745,7 +1658,7 @@
         </p:nvSpPr>
         <p:spPr>
           <a:xfrm>
-            <a:off x="8046720" y="1408176"/>
+            <a:off x="8046720" y="1879091"/>
             <a:ext cx="457200" cy="292608"/>
           </a:xfrm>
           <a:prstGeom prst="roundRect">
@@ -1781,7 +1694,7 @@
         </p:nvSpPr>
         <p:spPr>
           <a:xfrm>
-            <a:off x="8046720" y="1408176"/>
+            <a:off x="8046720" y="1879091"/>
             <a:ext cx="457200" cy="292608"/>
           </a:xfrm>
           <a:prstGeom prst="rect">
@@ -1817,8 +1730,8 @@
         </p:nvSpPr>
         <p:spPr>
           <a:xfrm>
-            <a:off x="8641080" y="1051560"/>
-            <a:ext cx="1764792" cy="1005840"/>
+            <a:off x="8641080" y="1645920"/>
+            <a:ext cx="1764792" cy="758952"/>
           </a:xfrm>
           <a:prstGeom prst="rect">
             <a:avLst/>
@@ -1834,7 +1747,7 @@
               <a:buNone/>
             </a:pPr>
             <a:r>
-              <a:rPr lang="es-SV" sz="1300" b="1" noProof="0" dirty="0">
+              <a:rPr lang="es-SV" sz="1150" b="1" noProof="0" dirty="0">
                 <a:solidFill>
                   <a:schemeClr val="tx1"/>
                 </a:solidFill>
@@ -1853,8 +1766,8 @@
         </p:nvSpPr>
         <p:spPr>
           <a:xfrm>
-            <a:off x="10451592" y="1051560"/>
-            <a:ext cx="1143000" cy="1005840"/>
+            <a:off x="10451592" y="1645920"/>
+            <a:ext cx="1143000" cy="758952"/>
           </a:xfrm>
           <a:prstGeom prst="rect">
             <a:avLst/>
@@ -1870,7 +1783,7 @@
               <a:buNone/>
             </a:pPr>
             <a:r>
-              <a:rPr lang="es-SV" sz="1200" noProof="0" dirty="0">
+              <a:rPr lang="es-SV" sz="1100" noProof="0" dirty="0">
                 <a:solidFill>
                   <a:schemeClr val="accent5"/>
                 </a:solidFill>
@@ -1889,7 +1802,7 @@
         </p:nvSpPr>
         <p:spPr>
           <a:xfrm>
-            <a:off x="8046720" y="2057400"/>
+            <a:off x="8046720" y="2404872"/>
             <a:ext cx="3502152" cy="0"/>
           </a:xfrm>
           <a:prstGeom prst="line">
@@ -1919,7 +1832,7 @@
         </p:nvSpPr>
         <p:spPr>
           <a:xfrm>
-            <a:off x="8046720" y="2414016"/>
+            <a:off x="8046720" y="2638044"/>
             <a:ext cx="457200" cy="292608"/>
           </a:xfrm>
           <a:prstGeom prst="roundRect">
@@ -1955,7 +1868,7 @@
         </p:nvSpPr>
         <p:spPr>
           <a:xfrm>
-            <a:off x="8046720" y="2414016"/>
+            <a:off x="8046720" y="2638044"/>
             <a:ext cx="457200" cy="292608"/>
           </a:xfrm>
           <a:prstGeom prst="rect">
@@ -1991,8 +1904,8 @@
         </p:nvSpPr>
         <p:spPr>
           <a:xfrm>
-            <a:off x="8641080" y="2057400"/>
-            <a:ext cx="1764792" cy="1005840"/>
+            <a:off x="8641080" y="2404872"/>
+            <a:ext cx="1874519" cy="758952"/>
           </a:xfrm>
           <a:prstGeom prst="rect">
             <a:avLst/>
@@ -2008,7 +1921,7 @@
               <a:buNone/>
             </a:pPr>
             <a:r>
-              <a:rPr lang="es-SV" sz="1300" b="1" noProof="0" dirty="0">
+              <a:rPr lang="es-SV" sz="1150" b="1" noProof="0" dirty="0">
                 <a:solidFill>
                   <a:schemeClr val="tx1"/>
                 </a:solidFill>
@@ -2027,8 +1940,8 @@
         </p:nvSpPr>
         <p:spPr>
           <a:xfrm>
-            <a:off x="10451592" y="2057400"/>
-            <a:ext cx="1143000" cy="1005840"/>
+            <a:off x="10451592" y="2404872"/>
+            <a:ext cx="1143000" cy="758952"/>
           </a:xfrm>
           <a:prstGeom prst="rect">
             <a:avLst/>
@@ -2044,7 +1957,7 @@
               <a:buNone/>
             </a:pPr>
             <a:r>
-              <a:rPr lang="es-SV" sz="1200" noProof="0" dirty="0">
+              <a:rPr lang="es-SV" sz="1100" noProof="0" dirty="0">
                 <a:solidFill>
                   <a:schemeClr val="accent5"/>
                 </a:solidFill>
@@ -2936,7 +2849,7 @@
           </a:prstGeom>
           <a:extLst>
             <a:ext uri="{C572A759-6A51-4108-AA02-DFA0A04FC94B}">
-              <ma14:wrappingTextBoxFlag xmlns="" xmlns:ma14="http://schemas.microsoft.com/office/mac/drawingml/2011/main" val="0"/>
+              <ma14:wrappingTextBoxFlag xmlns:ma14="http://schemas.microsoft.com/office/mac/drawingml/2011/main" xmlns="" val="0"/>
             </a:ext>
           </a:extLst>
         </p:spPr>
@@ -3037,6 +2950,7 @@
           <a:lstStyle/>
           <a:p>
             <a:pPr algn="ctr"/>
+            <a:endParaRPr/>
           </a:p>
         </p:txBody>
       </p:sp>
@@ -3083,6 +2997,7 @@
           <a:lstStyle/>
           <a:p>
             <a:pPr algn="ctr"/>
+            <a:endParaRPr/>
           </a:p>
         </p:txBody>
       </p:sp>
@@ -3103,7 +3018,7 @@
           <a:noFill/>
         </p:spPr>
         <p:txBody>
-          <a:bodyPr wrap="square" anchor="t" lIns="0" rIns="0" tIns="0" bIns="0">
+          <a:bodyPr wrap="square" lIns="0" tIns="0" rIns="0" bIns="0" anchor="t">
             <a:spAutoFit/>
           </a:bodyPr>
           <a:lstStyle/>
@@ -3138,7 +3053,7 @@
           <a:noFill/>
         </p:spPr>
         <p:txBody>
-          <a:bodyPr wrap="square" anchor="ctr" lIns="0" rIns="0" tIns="0" bIns="0">
+          <a:bodyPr wrap="square" lIns="0" tIns="0" rIns="0" bIns="0" anchor="ctr">
             <a:spAutoFit/>
           </a:bodyPr>
           <a:lstStyle/>
@@ -3173,7 +3088,7 @@
           <a:noFill/>
         </p:spPr>
         <p:txBody>
-          <a:bodyPr wrap="square" anchor="t" lIns="0" rIns="0" tIns="0" bIns="0">
+          <a:bodyPr wrap="square" lIns="0" tIns="0" rIns="0" bIns="0" anchor="t">
             <a:spAutoFit/>
           </a:bodyPr>
           <a:lstStyle/>
@@ -3208,7 +3123,7 @@
           <a:noFill/>
         </p:spPr>
         <p:txBody>
-          <a:bodyPr wrap="square" anchor="t" lIns="0" rIns="0" tIns="0" bIns="0">
+          <a:bodyPr wrap="square" lIns="0" tIns="0" rIns="0" bIns="0" anchor="t">
             <a:spAutoFit/>
           </a:bodyPr>
           <a:lstStyle/>
@@ -3243,7 +3158,7 @@
           <a:noFill/>
         </p:spPr>
         <p:txBody>
-          <a:bodyPr wrap="square" anchor="ctr" lIns="0" rIns="0" tIns="0" bIns="0">
+          <a:bodyPr wrap="square" lIns="0" tIns="0" rIns="0" bIns="0" anchor="ctr">
             <a:spAutoFit/>
           </a:bodyPr>
           <a:lstStyle/>
@@ -3278,7 +3193,7 @@
           <a:noFill/>
         </p:spPr>
         <p:txBody>
-          <a:bodyPr wrap="square" anchor="t" lIns="0" rIns="0" tIns="0" bIns="0">
+          <a:bodyPr wrap="square" lIns="0" tIns="0" rIns="0" bIns="0" anchor="t">
             <a:spAutoFit/>
           </a:bodyPr>
           <a:lstStyle/>
@@ -3333,94 +3248,47 @@
       </p:cxnSp>
       <p:sp>
         <p:nvSpPr>
-          <p:cNvPr id="58" name="Tipo visita"/>
-          <p:cNvSpPr txBox="1"/>
-          <p:nvPr/>
-        </p:nvSpPr>
-        <p:spPr>
-          <a:xfrm>
-            <a:off x="4242816" y="1042415"/>
-            <a:ext cx="1453895" cy="566928"/>
-          </a:xfrm>
-          <a:prstGeom prst="rect">
-            <a:avLst/>
-          </a:prstGeom>
-          <a:noFill/>
-        </p:spPr>
-        <p:txBody>
-          <a:bodyPr wrap="square" anchor="t" lIns="0" rIns="0" tIns="0" bIns="0">
+          <p:cNvPr id="59" name="Circular visita"/>
+          <p:cNvSpPr txBox="1"/>
+          <p:nvPr/>
+        </p:nvSpPr>
+        <p:spPr>
+          <a:xfrm>
+            <a:off x="4242817" y="1572768"/>
+            <a:ext cx="1453895" cy="384048"/>
+          </a:xfrm>
+          <a:prstGeom prst="rect">
+            <a:avLst/>
+          </a:prstGeom>
+          <a:noFill/>
+        </p:spPr>
+        <p:txBody>
+          <a:bodyPr wrap="square" lIns="0" tIns="0" rIns="0" bIns="0" anchor="t">
             <a:spAutoFit/>
           </a:bodyPr>
           <a:lstStyle/>
           <a:p>
             <a:pPr algn="l"/>
             <a:r>
-              <a:rPr sz="1200" b="1">
-                <a:solidFill>
-                  <a:srgbClr val="142033"/>
+              <a:rPr sz="1000" b="0" dirty="0">
+                <a:solidFill>
+                  <a:srgbClr val="586579"/>
                 </a:solidFill>
                 <a:latin typeface="Calibri"/>
               </a:rPr>
-              <a:t>Visita de supervisión ampliada</a:t>
-            </a:r>
-          </a:p>
-        </p:txBody>
-      </p:sp>
-      <p:sp>
-        <p:nvSpPr>
-          <p:cNvPr id="59" name="Circular visita"/>
-          <p:cNvSpPr txBox="1"/>
-          <p:nvPr/>
-        </p:nvSpPr>
-        <p:spPr>
-          <a:xfrm>
-            <a:off x="4242816" y="1572768"/>
-            <a:ext cx="1453895" cy="502920"/>
-          </a:xfrm>
-          <a:prstGeom prst="rect">
-            <a:avLst/>
-          </a:prstGeom>
-          <a:noFill/>
-        </p:spPr>
-        <p:txBody>
-          <a:bodyPr wrap="square" anchor="t" lIns="0" rIns="0" tIns="0" bIns="0">
-            <a:spAutoFit/>
-          </a:bodyPr>
-          <a:lstStyle/>
+              <a:t>Circular No.</a:t>
+            </a:r>
+          </a:p>
           <a:p>
             <a:pPr algn="l"/>
             <a:r>
-              <a:rPr sz="1000" b="0">
-                <a:solidFill>
-                  <a:srgbClr val="586579"/>
+              <a:rPr sz="1000" b="1" dirty="0">
+                <a:solidFill>
+                  <a:srgbClr val="173A6E"/>
                 </a:solidFill>
                 <a:latin typeface="Calibri"/>
               </a:rPr>
-              <a:t>Circular No.</a:t>
-            </a:r>
-          </a:p>
-          <a:p>
-            <a:pPr algn="l"/>
-            <a:r>
-              <a:rPr sz="1000" b="1">
-                <a:solidFill>
-                  <a:srgbClr val="173A6E"/>
-                </a:solidFill>
-                <a:latin typeface="Calibri"/>
-              </a:rPr>
-              <a:t>DS-SABAO-BCS-BC-23486</a:t>
-            </a:r>
-          </a:p>
-          <a:p>
-            <a:pPr algn="l"/>
-            <a:r>
-              <a:rPr sz="1000" b="1">
-                <a:solidFill>
-                  <a:srgbClr val="173A6E"/>
-                </a:solidFill>
-                <a:latin typeface="Calibri"/>
-              </a:rPr>
-              <a:t>02/10/2026</a:t>
+              <a:t>SABAO-BCS-BC-15527</a:t>
             </a:r>
           </a:p>
         </p:txBody>
@@ -3433,7 +3301,7 @@
         </p:nvCxnSpPr>
         <p:spPr>
           <a:xfrm>
-            <a:off x="4242816" y="2432304"/>
+            <a:off x="4215384" y="2037668"/>
             <a:ext cx="1453896" cy="0"/>
           </a:xfrm>
           <a:prstGeom prst="line">
@@ -3468,7 +3336,7 @@
         </p:nvSpPr>
         <p:spPr>
           <a:xfrm>
-            <a:off x="4242816" y="2505456"/>
+            <a:off x="4262870" y="2194560"/>
             <a:ext cx="1453895" cy="274320"/>
           </a:xfrm>
           <a:prstGeom prst="rect">
@@ -3477,14 +3345,14 @@
           <a:noFill/>
         </p:spPr>
         <p:txBody>
-          <a:bodyPr wrap="square" anchor="ctr" lIns="0" rIns="0" tIns="0" bIns="0">
+          <a:bodyPr wrap="square" lIns="0" tIns="0" rIns="0" bIns="0" anchor="ctr">
             <a:spAutoFit/>
           </a:bodyPr>
           <a:lstStyle/>
           <a:p>
             <a:pPr algn="l"/>
             <a:r>
-              <a:rPr sz="1100" b="0">
+              <a:rPr sz="1100" b="0" dirty="0">
                 <a:solidFill>
                   <a:srgbClr val="586579"/>
                 </a:solidFill>
@@ -3493,7 +3361,7 @@
               <a:t>Corte  </a:t>
             </a:r>
             <a:r>
-              <a:rPr sz="1100" b="1">
+              <a:rPr sz="1100" b="1" dirty="0">
                 <a:solidFill>
                   <a:srgbClr val="142033"/>
                 </a:solidFill>
@@ -3512,7 +3380,7 @@
         </p:nvCxnSpPr>
         <p:spPr>
           <a:xfrm>
-            <a:off x="4242816" y="2834640"/>
+            <a:off x="4242817" y="2649193"/>
             <a:ext cx="1453896" cy="0"/>
           </a:xfrm>
           <a:prstGeom prst="line">
@@ -3579,9 +3447,174 @@
           <a:lstStyle/>
           <a:p>
             <a:pPr algn="ctr"/>
-          </a:p>
-        </p:txBody>
-      </p:sp>
+            <a:endParaRPr/>
+          </a:p>
+        </p:txBody>
+      </p:sp>
+      <p:sp>
+        <p:nvSpPr>
+          <p:cNvPr id="64" name="Tipo visita"/>
+          <p:cNvSpPr txBox="1"/>
+          <p:nvPr/>
+        </p:nvSpPr>
+        <p:spPr>
+          <a:xfrm>
+            <a:off x="4242816" y="1024128"/>
+            <a:ext cx="1508760" cy="502920"/>
+          </a:xfrm>
+          <a:prstGeom prst="rect">
+            <a:avLst/>
+          </a:prstGeom>
+          <a:noFill/>
+        </p:spPr>
+        <p:txBody>
+          <a:bodyPr wrap="square" anchor="t" lIns="0" rIns="0" tIns="0" bIns="0">
+            <a:spAutoFit/>
+          </a:bodyPr>
+          <a:lstStyle/>
+          <a:p>
+            <a:r>
+              <a:rPr sz="1200" b="1">
+                <a:solidFill>
+                  <a:srgbClr val="142033"/>
+                </a:solidFill>
+                <a:latin typeface="Calibri"/>
+              </a:rPr>
+              <a:t>Nombramiento de visita ampliada</a:t>
+            </a:r>
+          </a:p>
+        </p:txBody>
+      </p:sp>
+      <p:sp>
+        <p:nvSpPr>
+          <p:cNvPr id="65" name="Tipo resultados"/>
+          <p:cNvSpPr txBox="1"/>
+          <p:nvPr/>
+        </p:nvSpPr>
+        <p:spPr>
+          <a:xfrm>
+            <a:off x="8046720" y="1005840"/>
+            <a:ext cx="3529583" cy="274320"/>
+          </a:xfrm>
+          <a:prstGeom prst="rect">
+            <a:avLst/>
+          </a:prstGeom>
+          <a:noFill/>
+        </p:spPr>
+        <p:txBody>
+          <a:bodyPr wrap="square" anchor="t" lIns="0" rIns="0" tIns="0" bIns="0">
+            <a:spAutoFit/>
+          </a:bodyPr>
+          <a:lstStyle/>
+          <a:p>
+            <a:r>
+              <a:rPr sz="1300" b="1">
+                <a:solidFill>
+                  <a:srgbClr val="142033"/>
+                </a:solidFill>
+                <a:latin typeface="Calibri"/>
+              </a:rPr>
+              <a:t>Resultados preliminares</a:t>
+            </a:r>
+          </a:p>
+        </p:txBody>
+      </p:sp>
+      <p:sp>
+        <p:nvSpPr>
+          <p:cNvPr id="66" name="Circular resultados"/>
+          <p:cNvSpPr txBox="1"/>
+          <p:nvPr/>
+        </p:nvSpPr>
+        <p:spPr>
+          <a:xfrm>
+            <a:off x="8046720" y="1298448"/>
+            <a:ext cx="3529583" cy="228600"/>
+          </a:xfrm>
+          <a:prstGeom prst="rect">
+            <a:avLst/>
+          </a:prstGeom>
+          <a:noFill/>
+        </p:spPr>
+        <p:txBody>
+          <a:bodyPr wrap="square" anchor="t" lIns="0" rIns="0" tIns="0" bIns="0">
+            <a:spAutoFit/>
+          </a:bodyPr>
+          <a:lstStyle/>
+          <a:p>
+            <a:r>
+              <a:rPr sz="1000" b="0">
+                <a:solidFill>
+                  <a:srgbClr val="586579"/>
+                </a:solidFill>
+                <a:latin typeface="Calibri"/>
+              </a:rPr>
+              <a:t>Circular No.  </a:t>
+            </a:r>
+            <a:r>
+              <a:rPr sz="1000" b="1">
+                <a:solidFill>
+                  <a:srgbClr val="173A6E"/>
+                </a:solidFill>
+                <a:latin typeface="Calibri"/>
+              </a:rPr>
+              <a:t>DS-SABAO-BCS-BC-23486</a:t>
+            </a:r>
+            <a:r>
+              <a:rPr sz="1100" b="0">
+                <a:solidFill>
+                  <a:srgbClr val="142033"/>
+                </a:solidFill>
+                <a:latin typeface="Calibri"/>
+              </a:rPr>
+              <a:t>   </a:t>
+            </a:r>
+            <a:r>
+              <a:rPr sz="1000" b="1">
+                <a:solidFill>
+                  <a:srgbClr val="173A6E"/>
+                </a:solidFill>
+                <a:latin typeface="Calibri"/>
+              </a:rPr>
+              <a:t>02/10/2026</a:t>
+            </a:r>
+          </a:p>
+        </p:txBody>
+      </p:sp>
+      <p:cxnSp>
+        <p:nvCxnSpPr>
+          <p:cNvPr id="67" name="Connector 66"/>
+          <p:cNvCxnSpPr/>
+          <p:nvPr/>
+        </p:nvCxnSpPr>
+        <p:spPr>
+          <a:xfrm>
+            <a:off x="8046720" y="1591056"/>
+            <a:ext cx="3529584" cy="0"/>
+          </a:xfrm>
+          <a:prstGeom prst="line">
+            <a:avLst/>
+          </a:prstGeom>
+          <a:ln w="9525">
+            <a:solidFill>
+              <a:srgbClr val="D9E0EA"/>
+            </a:solidFill>
+          </a:ln>
+        </p:spPr>
+        <p:style>
+          <a:lnRef idx="2">
+            <a:schemeClr val="accent1"/>
+          </a:lnRef>
+          <a:fillRef idx="0">
+            <a:schemeClr val="accent1"/>
+          </a:fillRef>
+          <a:effectRef idx="1">
+            <a:schemeClr val="accent1"/>
+          </a:effectRef>
+          <a:fontRef idx="minor">
+            <a:schemeClr val="tx1"/>
+          </a:fontRef>
+        </p:style>
+      </p:cxnSp>
     </p:spTree>
   </p:cSld>
   <p:clrMapOvr>
@@ -3994,9 +4027,7 @@
           <a:bodyPr wrap="square" lIns="0" tIns="0" rIns="0" bIns="0" rtlCol="0" anchor="t"/>
           <a:lstStyle/>
           <a:p>
-            <a:pPr marL="0" indent="0" algn="just">
-              <a:buNone/>
-            </a:pPr>
+            <a:pPr algn="just"/>
             <a:r>
               <a:rPr lang="es-SV" sz="850" b="1" noProof="0" dirty="0">
                 <a:solidFill>
@@ -4006,12 +4037,22 @@
               <a:t>Comentarios  </a:t>
             </a:r>
             <a:r>
-              <a:rPr lang="es-SV" sz="850" b="1" noProof="0" dirty="0">
+              <a:rPr lang="es-SV" sz="800" b="1" dirty="0">
+                <a:solidFill>
+                  <a:schemeClr val="accent4">
+                    <a:lumMod val="75000"/>
+                  </a:schemeClr>
+                </a:solidFill>
+              </a:rPr>
+              <a:t>Se incorporará prueba de descargo</a:t>
+            </a:r>
+            <a:r>
+              <a:rPr lang="es-SV" sz="850" b="1" dirty="0">
                 <a:solidFill>
                   <a:schemeClr val="accent6"/>
                 </a:solidFill>
               </a:rPr>
-              <a:t>Pendiente</a:t>
+              <a:t> </a:t>
             </a:r>
             <a:endParaRPr lang="es-SV" sz="850" noProof="0" dirty="0"/>
           </a:p>
@@ -4220,7 +4261,7 @@
         </p:nvSpPr>
         <p:spPr>
           <a:xfrm>
-            <a:off x="6306160" y="2547747"/>
+            <a:off x="6340814" y="2542735"/>
             <a:ext cx="5282032" cy="200580"/>
           </a:xfrm>
           <a:prstGeom prst="rect">
@@ -4233,26 +4274,25 @@
           <a:bodyPr wrap="square" lIns="0" tIns="0" rIns="0" bIns="0" rtlCol="0" anchor="t"/>
           <a:lstStyle/>
           <a:p>
-            <a:pPr marL="0" indent="0" algn="just">
-              <a:buNone/>
-            </a:pPr>
+            <a:pPr algn="just"/>
             <a:r>
               <a:rPr lang="es-SV" sz="850" b="1" noProof="0" dirty="0">
                 <a:solidFill>
                   <a:schemeClr val="accent5"/>
                 </a:solidFill>
               </a:rPr>
-              <a:t>Comentarios  </a:t>
-            </a:r>
-            <a:r>
-              <a:rPr lang="es-SV" sz="850" b="1" noProof="0" dirty="0">
-                <a:solidFill>
-                  <a:schemeClr val="accent6"/>
-                </a:solidFill>
-              </a:rPr>
-              <a:t>Pendiente</a:t>
-            </a:r>
-            <a:endParaRPr lang="es-SV" sz="850" noProof="0" dirty="0"/>
+              <a:t>Comentarios </a:t>
+            </a:r>
+            <a:r>
+              <a:rPr lang="es-SV" sz="800" b="1" dirty="0">
+                <a:solidFill>
+                  <a:schemeClr val="accent4">
+                    <a:lumMod val="75000"/>
+                  </a:schemeClr>
+                </a:solidFill>
+              </a:rPr>
+              <a:t>Se incorporará prueba de descargo </a:t>
+            </a:r>
           </a:p>
         </p:txBody>
       </p:sp>
@@ -4525,50 +4565,6 @@
       </p:sp>
       <p:sp>
         <p:nvSpPr>
-          <p:cNvPr id="26" name="Comentario B.1"/>
-          <p:cNvSpPr txBox="1"/>
-          <p:nvPr/>
-        </p:nvSpPr>
-        <p:spPr>
-          <a:xfrm>
-            <a:off x="603504" y="4478829"/>
-            <a:ext cx="3381146" cy="202081"/>
-          </a:xfrm>
-          <a:prstGeom prst="rect">
-            <a:avLst/>
-          </a:prstGeom>
-          <a:noFill/>
-          <a:ln/>
-        </p:spPr>
-        <p:txBody>
-          <a:bodyPr wrap="square" lIns="0" tIns="0" rIns="0" bIns="0" rtlCol="0" anchor="t"/>
-          <a:lstStyle/>
-          <a:p>
-            <a:pPr marL="0" indent="0" algn="just">
-              <a:buNone/>
-            </a:pPr>
-            <a:r>
-              <a:rPr lang="es-SV" sz="850" b="1" noProof="0" dirty="0">
-                <a:solidFill>
-                  <a:schemeClr val="accent5"/>
-                </a:solidFill>
-              </a:rPr>
-              <a:t>Comentarios  </a:t>
-            </a:r>
-            <a:r>
-              <a:rPr lang="es-SV" sz="850" b="1" noProof="0" dirty="0">
-                <a:solidFill>
-                  <a:schemeClr val="accent6"/>
-                </a:solidFill>
-              </a:rPr>
-              <a:t>Pendiente</a:t>
-            </a:r>
-            <a:endParaRPr lang="es-SV" sz="850" noProof="0" dirty="0"/>
-          </a:p>
-        </p:txBody>
-      </p:sp>
-      <p:sp>
-        <p:nvSpPr>
           <p:cNvPr id="27" name="Obs B.2"/>
           <p:cNvSpPr/>
           <p:nvPr/>
@@ -4764,50 +4760,6 @@
       </p:sp>
       <p:sp>
         <p:nvSpPr>
-          <p:cNvPr id="32" name="Comentario B.2"/>
-          <p:cNvSpPr txBox="1"/>
-          <p:nvPr/>
-        </p:nvSpPr>
-        <p:spPr>
-          <a:xfrm>
-            <a:off x="4405274" y="4478829"/>
-            <a:ext cx="3381146" cy="202081"/>
-          </a:xfrm>
-          <a:prstGeom prst="rect">
-            <a:avLst/>
-          </a:prstGeom>
-          <a:noFill/>
-          <a:ln/>
-        </p:spPr>
-        <p:txBody>
-          <a:bodyPr wrap="square" lIns="0" tIns="0" rIns="0" bIns="0" rtlCol="0" anchor="t"/>
-          <a:lstStyle/>
-          <a:p>
-            <a:pPr marL="0" indent="0" algn="just">
-              <a:buNone/>
-            </a:pPr>
-            <a:r>
-              <a:rPr lang="es-SV" sz="850" b="1" noProof="0" dirty="0">
-                <a:solidFill>
-                  <a:schemeClr val="accent5"/>
-                </a:solidFill>
-              </a:rPr>
-              <a:t>Comentarios  </a:t>
-            </a:r>
-            <a:r>
-              <a:rPr lang="es-SV" sz="850" b="1" noProof="0" dirty="0">
-                <a:solidFill>
-                  <a:schemeClr val="accent6"/>
-                </a:solidFill>
-              </a:rPr>
-              <a:t>Pendiente</a:t>
-            </a:r>
-            <a:endParaRPr lang="es-SV" sz="850" noProof="0" dirty="0"/>
-          </a:p>
-        </p:txBody>
-      </p:sp>
-      <p:sp>
-        <p:nvSpPr>
           <p:cNvPr id="33" name="Obs B.3"/>
           <p:cNvSpPr/>
           <p:nvPr/>
@@ -5003,50 +4955,6 @@
       </p:sp>
       <p:sp>
         <p:nvSpPr>
-          <p:cNvPr id="38" name="Comentario B.3"/>
-          <p:cNvSpPr txBox="1"/>
-          <p:nvPr/>
-        </p:nvSpPr>
-        <p:spPr>
-          <a:xfrm>
-            <a:off x="8207045" y="4478829"/>
-            <a:ext cx="3381146" cy="202081"/>
-          </a:xfrm>
-          <a:prstGeom prst="rect">
-            <a:avLst/>
-          </a:prstGeom>
-          <a:noFill/>
-          <a:ln/>
-        </p:spPr>
-        <p:txBody>
-          <a:bodyPr wrap="square" lIns="0" tIns="0" rIns="0" bIns="0" rtlCol="0" anchor="t"/>
-          <a:lstStyle/>
-          <a:p>
-            <a:pPr marL="0" indent="0" algn="just">
-              <a:buNone/>
-            </a:pPr>
-            <a:r>
-              <a:rPr lang="es-SV" sz="850" b="1" noProof="0" dirty="0">
-                <a:solidFill>
-                  <a:schemeClr val="accent5"/>
-                </a:solidFill>
-              </a:rPr>
-              <a:t>Comentarios  </a:t>
-            </a:r>
-            <a:r>
-              <a:rPr lang="es-SV" sz="850" b="1" noProof="0" dirty="0">
-                <a:solidFill>
-                  <a:schemeClr val="accent6"/>
-                </a:solidFill>
-              </a:rPr>
-              <a:t>Pendiente</a:t>
-            </a:r>
-            <a:endParaRPr lang="es-SV" sz="850" noProof="0" dirty="0"/>
-          </a:p>
-        </p:txBody>
-      </p:sp>
-      <p:sp>
-        <p:nvSpPr>
           <p:cNvPr id="39" name="Obs B.4"/>
           <p:cNvSpPr/>
           <p:nvPr/>
@@ -5054,7 +4962,7 @@
         <p:spPr>
           <a:xfrm>
             <a:off x="457200" y="4900366"/>
-            <a:ext cx="3673754" cy="1500434"/>
+            <a:ext cx="3673754" cy="1610162"/>
           </a:xfrm>
           <a:prstGeom prst="roundRect">
             <a:avLst>
@@ -5212,7 +5120,7 @@
         </p:nvSpPr>
         <p:spPr>
           <a:xfrm>
-            <a:off x="603504" y="5577022"/>
+            <a:off x="621792" y="5501012"/>
             <a:ext cx="3381146" cy="340614"/>
           </a:xfrm>
           <a:prstGeom prst="rect">
@@ -5248,8 +5156,8 @@
         </p:nvSpPr>
         <p:spPr>
           <a:xfrm>
-            <a:off x="603504" y="5990788"/>
-            <a:ext cx="3381146" cy="318572"/>
+            <a:off x="566928" y="5877689"/>
+            <a:ext cx="3417722" cy="548380"/>
           </a:xfrm>
           <a:prstGeom prst="rect">
             <a:avLst/>
@@ -5261,26 +5169,42 @@
           <a:bodyPr wrap="square" lIns="0" tIns="0" rIns="0" bIns="0" rtlCol="0" anchor="t"/>
           <a:lstStyle/>
           <a:p>
-            <a:pPr marL="0" indent="0" algn="just">
-              <a:buNone/>
-            </a:pPr>
-            <a:r>
-              <a:rPr lang="es-SV" sz="850" b="1" noProof="0" dirty="0">
+            <a:pPr algn="just">
+              <a:buNone/>
+            </a:pPr>
+            <a:r>
+              <a:rPr lang="es-SV" sz="750" b="1" noProof="0" dirty="0">
                 <a:solidFill>
                   <a:schemeClr val="accent5"/>
                 </a:solidFill>
               </a:rPr>
-              <a:t>Comentarios  </a:t>
-            </a:r>
-            <a:r>
-              <a:rPr lang="es-SV" sz="850" b="1" noProof="0" dirty="0">
-                <a:solidFill>
-                  <a:schemeClr val="accent6"/>
-                </a:solidFill>
-              </a:rPr>
-              <a:t>Pendiente</a:t>
-            </a:r>
-            <a:endParaRPr lang="es-SV" sz="850" noProof="0" dirty="0"/>
+              <a:t>Comentarios </a:t>
+            </a:r>
+            <a:r>
+              <a:rPr lang="es-SV" sz="750" b="1" dirty="0">
+                <a:solidFill>
+                  <a:schemeClr val="accent4">
+                    <a:lumMod val="75000"/>
+                  </a:schemeClr>
+                </a:solidFill>
+              </a:rPr>
+              <a:t>El artículo 61 no exige la automatización de las validaciones en listas de cautela, sino tecnología proporcional a la naturaleza, tamaño, operaciones y nivel de riesgo de cada entidad.</a:t>
+            </a:r>
+          </a:p>
+          <a:p>
+            <a:pPr algn="just">
+              <a:buNone/>
+            </a:pPr>
+            <a:r>
+              <a:rPr lang="es-SV" sz="750" b="1" dirty="0">
+                <a:solidFill>
+                  <a:schemeClr val="accent4">
+                    <a:lumMod val="75000"/>
+                  </a:schemeClr>
+                </a:solidFill>
+              </a:rPr>
+              <a:t>Como COMEDICA realiza y documenta dichas validaciones, se solicita reclasificar el hallazgo como recomendación de mejora y no como incumplimiento normativo.</a:t>
+            </a:r>
           </a:p>
         </p:txBody>
       </p:sp>
@@ -5293,7 +5217,7 @@
         <p:spPr>
           <a:xfrm>
             <a:off x="4258970" y="4900366"/>
-            <a:ext cx="3673754" cy="1500434"/>
+            <a:ext cx="3673754" cy="1581080"/>
           </a:xfrm>
           <a:prstGeom prst="roundRect">
             <a:avLst>
@@ -5481,50 +5405,6 @@
       </p:sp>
       <p:sp>
         <p:nvSpPr>
-          <p:cNvPr id="50" name="Comentario B.5"/>
-          <p:cNvSpPr txBox="1"/>
-          <p:nvPr/>
-        </p:nvSpPr>
-        <p:spPr>
-          <a:xfrm>
-            <a:off x="4405274" y="5990788"/>
-            <a:ext cx="3381146" cy="318572"/>
-          </a:xfrm>
-          <a:prstGeom prst="rect">
-            <a:avLst/>
-          </a:prstGeom>
-          <a:noFill/>
-          <a:ln/>
-        </p:spPr>
-        <p:txBody>
-          <a:bodyPr wrap="square" lIns="0" tIns="0" rIns="0" bIns="0" rtlCol="0" anchor="t"/>
-          <a:lstStyle/>
-          <a:p>
-            <a:pPr marL="0" indent="0" algn="just">
-              <a:buNone/>
-            </a:pPr>
-            <a:r>
-              <a:rPr lang="es-SV" sz="850" b="1" noProof="0" dirty="0">
-                <a:solidFill>
-                  <a:schemeClr val="accent5"/>
-                </a:solidFill>
-              </a:rPr>
-              <a:t>Comentarios  </a:t>
-            </a:r>
-            <a:r>
-              <a:rPr lang="es-SV" sz="850" b="1" noProof="0" dirty="0">
-                <a:solidFill>
-                  <a:schemeClr val="accent6"/>
-                </a:solidFill>
-              </a:rPr>
-              <a:t>Pendiente</a:t>
-            </a:r>
-            <a:endParaRPr lang="es-SV" sz="850" noProof="0" dirty="0"/>
-          </a:p>
-        </p:txBody>
-      </p:sp>
-      <p:sp>
-        <p:nvSpPr>
           <p:cNvPr id="51" name="Obs B.6"/>
           <p:cNvSpPr/>
           <p:nvPr/>
@@ -5532,7 +5412,7 @@
         <p:spPr>
           <a:xfrm>
             <a:off x="8060741" y="4900366"/>
-            <a:ext cx="3673754" cy="1500434"/>
+            <a:ext cx="3673754" cy="1581080"/>
           </a:xfrm>
           <a:prstGeom prst="roundRect">
             <a:avLst>
@@ -5756,7 +5636,19 @@
                   <a:schemeClr val="tx1"/>
                 </a:solidFill>
               </a:rPr>
-              <a:t>Se anexa informe elaborado en fecha 13 de diciembre de 2024, sobre proyecto de implementación de un nuevo sistema de monitoreo de LDA/FT/FPADM y del sistema de fraude de canales digitales.</a:t>
+              <a:t>Se anexa informe elaborado por </a:t>
+            </a:r>
+            <a:r>
+              <a:rPr lang="es-SV" sz="850" dirty="0"/>
+              <a:t>jefatura de riesgo </a:t>
+            </a:r>
+            <a:r>
+              <a:rPr lang="es-SV" sz="850" noProof="0" dirty="0">
+                <a:solidFill>
+                  <a:schemeClr val="tx1"/>
+                </a:solidFill>
+              </a:rPr>
+              <a:t>en fecha 13 de diciembre de 2024, sobre proyecto de implementación de un nuevo sistema de monitoreo de LDA/FT/FPADM y del sistema de fraude de canales digitales</a:t>
             </a:r>
             <a:endParaRPr lang="es-SV" sz="850" noProof="0" dirty="0"/>
           </a:p>
@@ -5782,7 +5674,7 @@
           </a:prstGeom>
           <a:extLst>
             <a:ext uri="{C572A759-6A51-4108-AA02-DFA0A04FC94B}">
-              <ma14:wrappingTextBoxFlag xmlns="" xmlns:ma14="http://schemas.microsoft.com/office/mac/drawingml/2011/main" val="0"/>
+              <ma14:wrappingTextBoxFlag xmlns:ma14="http://schemas.microsoft.com/office/mac/drawingml/2011/main" xmlns="" val="0"/>
             </a:ext>
           </a:extLst>
         </p:spPr>
@@ -5804,6 +5696,202 @@
               <a:t>2</a:t>
             </a:fld>
             <a:endParaRPr lang="es-SV" noProof="0" dirty="0"/>
+          </a:p>
+        </p:txBody>
+      </p:sp>
+      <p:sp>
+        <p:nvSpPr>
+          <p:cNvPr id="59" name="Comentario A.2">
+            <a:extLst>
+              <a:ext uri="{FF2B5EF4-FFF2-40B4-BE49-F238E27FC236}">
+                <a16:creationId xmlns:a16="http://schemas.microsoft.com/office/drawing/2014/main" id="{4BD6DC5D-1D24-4503-2731-091715DA73BC}"/>
+              </a:ext>
+            </a:extLst>
+          </p:cNvPr>
+          <p:cNvSpPr txBox="1"/>
+          <p:nvPr/>
+        </p:nvSpPr>
+        <p:spPr>
+          <a:xfrm>
+            <a:off x="603504" y="4526344"/>
+            <a:ext cx="2684819" cy="200580"/>
+          </a:xfrm>
+          <a:prstGeom prst="rect">
+            <a:avLst/>
+          </a:prstGeom>
+          <a:noFill/>
+          <a:ln/>
+        </p:spPr>
+        <p:txBody>
+          <a:bodyPr wrap="square" lIns="0" tIns="0" rIns="0" bIns="0" rtlCol="0" anchor="t"/>
+          <a:lstStyle/>
+          <a:p>
+            <a:pPr algn="just"/>
+            <a:r>
+              <a:rPr lang="es-SV" sz="850" b="1" noProof="0" dirty="0">
+                <a:solidFill>
+                  <a:schemeClr val="accent5"/>
+                </a:solidFill>
+              </a:rPr>
+              <a:t>Comentarios </a:t>
+            </a:r>
+            <a:r>
+              <a:rPr lang="es-SV" sz="800" b="1" dirty="0">
+                <a:solidFill>
+                  <a:schemeClr val="accent4">
+                    <a:lumMod val="75000"/>
+                  </a:schemeClr>
+                </a:solidFill>
+              </a:rPr>
+              <a:t>Se incorporará prueba de descargo </a:t>
+            </a:r>
+          </a:p>
+        </p:txBody>
+      </p:sp>
+      <p:sp>
+        <p:nvSpPr>
+          <p:cNvPr id="60" name="Comentario A.2">
+            <a:extLst>
+              <a:ext uri="{FF2B5EF4-FFF2-40B4-BE49-F238E27FC236}">
+                <a16:creationId xmlns:a16="http://schemas.microsoft.com/office/drawing/2014/main" id="{F78424E6-D1DC-99D3-19D0-71DB6E0F2B8A}"/>
+              </a:ext>
+            </a:extLst>
+          </p:cNvPr>
+          <p:cNvSpPr txBox="1"/>
+          <p:nvPr/>
+        </p:nvSpPr>
+        <p:spPr>
+          <a:xfrm>
+            <a:off x="4405274" y="4526344"/>
+            <a:ext cx="2684819" cy="200580"/>
+          </a:xfrm>
+          <a:prstGeom prst="rect">
+            <a:avLst/>
+          </a:prstGeom>
+          <a:noFill/>
+          <a:ln/>
+        </p:spPr>
+        <p:txBody>
+          <a:bodyPr wrap="square" lIns="0" tIns="0" rIns="0" bIns="0" rtlCol="0" anchor="t"/>
+          <a:lstStyle/>
+          <a:p>
+            <a:pPr algn="just"/>
+            <a:r>
+              <a:rPr lang="es-SV" sz="850" b="1" noProof="0" dirty="0">
+                <a:solidFill>
+                  <a:schemeClr val="accent5"/>
+                </a:solidFill>
+              </a:rPr>
+              <a:t>Comentarios </a:t>
+            </a:r>
+            <a:r>
+              <a:rPr lang="es-SV" sz="800" b="1" dirty="0">
+                <a:solidFill>
+                  <a:schemeClr val="accent4">
+                    <a:lumMod val="75000"/>
+                  </a:schemeClr>
+                </a:solidFill>
+              </a:rPr>
+              <a:t>Se incorporará prueba de descargo </a:t>
+            </a:r>
+          </a:p>
+        </p:txBody>
+      </p:sp>
+      <p:sp>
+        <p:nvSpPr>
+          <p:cNvPr id="61" name="Comentario A.2">
+            <a:extLst>
+              <a:ext uri="{FF2B5EF4-FFF2-40B4-BE49-F238E27FC236}">
+                <a16:creationId xmlns:a16="http://schemas.microsoft.com/office/drawing/2014/main" id="{06B0EA24-F3E1-CE40-D5D8-493662943F32}"/>
+              </a:ext>
+            </a:extLst>
+          </p:cNvPr>
+          <p:cNvSpPr txBox="1"/>
+          <p:nvPr/>
+        </p:nvSpPr>
+        <p:spPr>
+          <a:xfrm>
+            <a:off x="8207045" y="4501753"/>
+            <a:ext cx="2684819" cy="200580"/>
+          </a:xfrm>
+          <a:prstGeom prst="rect">
+            <a:avLst/>
+          </a:prstGeom>
+          <a:noFill/>
+          <a:ln/>
+        </p:spPr>
+        <p:txBody>
+          <a:bodyPr wrap="square" lIns="0" tIns="0" rIns="0" bIns="0" rtlCol="0" anchor="t"/>
+          <a:lstStyle/>
+          <a:p>
+            <a:pPr algn="just"/>
+            <a:r>
+              <a:rPr lang="es-SV" sz="850" b="1" noProof="0" dirty="0">
+                <a:solidFill>
+                  <a:schemeClr val="accent5"/>
+                </a:solidFill>
+              </a:rPr>
+              <a:t>Comentarios </a:t>
+            </a:r>
+            <a:r>
+              <a:rPr lang="es-SV" sz="800" b="1" dirty="0">
+                <a:solidFill>
+                  <a:schemeClr val="accent4">
+                    <a:lumMod val="75000"/>
+                  </a:schemeClr>
+                </a:solidFill>
+              </a:rPr>
+              <a:t>Se incorporará prueba de descargo </a:t>
+            </a:r>
+          </a:p>
+        </p:txBody>
+      </p:sp>
+      <p:sp>
+        <p:nvSpPr>
+          <p:cNvPr id="62" name="Comentario A.2">
+            <a:extLst>
+              <a:ext uri="{FF2B5EF4-FFF2-40B4-BE49-F238E27FC236}">
+                <a16:creationId xmlns:a16="http://schemas.microsoft.com/office/drawing/2014/main" id="{18430647-13A6-DA94-6FE7-2499F677A283}"/>
+              </a:ext>
+            </a:extLst>
+          </p:cNvPr>
+          <p:cNvSpPr txBox="1"/>
+          <p:nvPr/>
+        </p:nvSpPr>
+        <p:spPr>
+          <a:xfrm>
+            <a:off x="4405274" y="6027364"/>
+            <a:ext cx="2684819" cy="200580"/>
+          </a:xfrm>
+          <a:prstGeom prst="rect">
+            <a:avLst/>
+          </a:prstGeom>
+          <a:noFill/>
+          <a:ln/>
+        </p:spPr>
+        <p:txBody>
+          <a:bodyPr wrap="square" lIns="0" tIns="0" rIns="0" bIns="0" rtlCol="0" anchor="t"/>
+          <a:lstStyle/>
+          <a:p>
+            <a:pPr algn="just"/>
+            <a:r>
+              <a:rPr lang="es-SV" sz="850" b="1" noProof="0" dirty="0">
+                <a:solidFill>
+                  <a:schemeClr val="accent5"/>
+                </a:solidFill>
+              </a:rPr>
+              <a:t>Comentarios </a:t>
+            </a:r>
+            <a:r>
+              <a:rPr lang="es-SV" sz="800" b="1" dirty="0">
+                <a:solidFill>
+                  <a:schemeClr val="accent4">
+                    <a:lumMod val="75000"/>
+                  </a:schemeClr>
+                </a:solidFill>
+              </a:rPr>
+              <a:t>Se incorporará prueba de descargo </a:t>
+            </a:r>
           </a:p>
         </p:txBody>
       </p:sp>
@@ -6183,25 +6271,32 @@
           <a:bodyPr wrap="square" lIns="0" tIns="0" rIns="0" bIns="0" rtlCol="0" anchor="t"/>
           <a:lstStyle/>
           <a:p>
+            <a:pPr algn="just"/>
+            <a:r>
+              <a:rPr lang="es-SV" sz="900" b="1" noProof="0" dirty="0">
+                <a:solidFill>
+                  <a:schemeClr val="accent5"/>
+                </a:solidFill>
+              </a:rPr>
+              <a:t>Comentarios  </a:t>
+            </a:r>
+            <a:r>
+              <a:rPr lang="es-SV" sz="900" noProof="0" dirty="0">
+                <a:solidFill>
+                  <a:schemeClr val="tx1"/>
+                </a:solidFill>
+              </a:rPr>
+              <a:t>Se adjuntará la propuesta de la Gerencia Legal por medio de correo de fecha 09 de octubre 2026, envió propuesta a la Gerencia de Cumplimiento y Seguridad de la Información para la modificación del contrato. Pendiente</a:t>
+            </a:r>
+            <a:r>
+              <a:rPr lang="es-SV" sz="900" dirty="0"/>
+              <a:t>; asimismo  Se incorporará prueba de descargo </a:t>
+            </a:r>
+          </a:p>
+          <a:p>
             <a:pPr marL="0" indent="0" algn="just">
               <a:buNone/>
             </a:pPr>
-            <a:r>
-              <a:rPr lang="es-SV" sz="900" b="1" noProof="0" dirty="0">
-                <a:solidFill>
-                  <a:schemeClr val="accent5"/>
-                </a:solidFill>
-              </a:rPr>
-              <a:t>Comentarios  </a:t>
-            </a:r>
-            <a:r>
-              <a:rPr lang="es-SV" sz="900" noProof="0" dirty="0">
-                <a:solidFill>
-                  <a:schemeClr val="tx1"/>
-                </a:solidFill>
-              </a:rPr>
-              <a:t>Se adjuntará la propuesta de la Gerencia Legal por medio de correo de fecha 09 de octubre 2026, envió propuesta a la Gerencia de Cumplimiento y Seguridad de la Información para la modificación del contrato. Pendiente</a:t>
-            </a:r>
             <a:endParaRPr lang="es-SV" sz="900" noProof="0" dirty="0"/>
           </a:p>
         </p:txBody>
@@ -7120,50 +7215,6 @@
       </p:sp>
       <p:sp>
         <p:nvSpPr>
-          <p:cNvPr id="36" name="Comentario B.11"/>
-          <p:cNvSpPr txBox="1"/>
-          <p:nvPr/>
-        </p:nvSpPr>
-        <p:spPr>
-          <a:xfrm>
-            <a:off x="4405274" y="4141810"/>
-            <a:ext cx="3381146" cy="407288"/>
-          </a:xfrm>
-          <a:prstGeom prst="rect">
-            <a:avLst/>
-          </a:prstGeom>
-          <a:noFill/>
-          <a:ln/>
-        </p:spPr>
-        <p:txBody>
-          <a:bodyPr wrap="square" lIns="0" tIns="0" rIns="0" bIns="0" rtlCol="0" anchor="t"/>
-          <a:lstStyle/>
-          <a:p>
-            <a:pPr marL="0" indent="0" algn="just">
-              <a:buNone/>
-            </a:pPr>
-            <a:r>
-              <a:rPr lang="es-SV" sz="900" b="1" noProof="0" dirty="0">
-                <a:solidFill>
-                  <a:schemeClr val="accent5"/>
-                </a:solidFill>
-              </a:rPr>
-              <a:t>Comentarios  </a:t>
-            </a:r>
-            <a:r>
-              <a:rPr lang="es-SV" sz="900" b="1" noProof="0" dirty="0">
-                <a:solidFill>
-                  <a:schemeClr val="accent6"/>
-                </a:solidFill>
-              </a:rPr>
-              <a:t>Pendiente</a:t>
-            </a:r>
-            <a:endParaRPr lang="es-SV" sz="900" noProof="0" dirty="0"/>
-          </a:p>
-        </p:txBody>
-      </p:sp>
-      <p:sp>
-        <p:nvSpPr>
           <p:cNvPr id="37" name="Slide Number Placeholder 0"/>
           <p:cNvSpPr>
             <a:spLocks noGrp="1"/>
@@ -7182,7 +7233,7 @@
           </a:prstGeom>
           <a:extLst>
             <a:ext uri="{C572A759-6A51-4108-AA02-DFA0A04FC94B}">
-              <ma14:wrappingTextBoxFlag xmlns="" xmlns:ma14="http://schemas.microsoft.com/office/mac/drawingml/2011/main" val="0"/>
+              <ma14:wrappingTextBoxFlag xmlns:ma14="http://schemas.microsoft.com/office/mac/drawingml/2011/main" xmlns="" val="0"/>
             </a:ext>
           </a:extLst>
         </p:spPr>
@@ -7434,56 +7485,6 @@
       </p:sp>
       <p:sp>
         <p:nvSpPr>
-          <p:cNvPr id="49" name="Comentario B.12">
-            <a:extLst>
-              <a:ext uri="{FF2B5EF4-FFF2-40B4-BE49-F238E27FC236}">
-                <a16:creationId xmlns:a16="http://schemas.microsoft.com/office/drawing/2014/main" id="{DAB72391-18DD-81FA-0A21-B79E9B4259C7}"/>
-              </a:ext>
-            </a:extLst>
-          </p:cNvPr>
-          <p:cNvSpPr txBox="1"/>
-          <p:nvPr/>
-        </p:nvSpPr>
-        <p:spPr>
-          <a:xfrm>
-            <a:off x="8225332" y="4280113"/>
-            <a:ext cx="3344571" cy="216407"/>
-          </a:xfrm>
-          <a:prstGeom prst="rect">
-            <a:avLst/>
-          </a:prstGeom>
-          <a:noFill/>
-          <a:ln/>
-        </p:spPr>
-        <p:txBody>
-          <a:bodyPr wrap="square" lIns="0" tIns="0" rIns="0" bIns="0" rtlCol="0" anchor="t"/>
-          <a:lstStyle/>
-          <a:p>
-            <a:pPr marL="0" indent="0" algn="just">
-              <a:buNone/>
-            </a:pPr>
-            <a:r>
-              <a:rPr lang="es-SV" sz="900" b="1" noProof="0" dirty="0">
-                <a:solidFill>
-                  <a:schemeClr val="accent5"/>
-                </a:solidFill>
-              </a:rPr>
-              <a:t>Comentarios  </a:t>
-            </a:r>
-            <a:r>
-              <a:rPr lang="es-SV" sz="900" b="1" noProof="0" dirty="0">
-                <a:solidFill>
-                  <a:schemeClr val="accent6"/>
-                </a:solidFill>
-              </a:rPr>
-              <a:t>Pendiente</a:t>
-            </a:r>
-            <a:endParaRPr lang="es-SV" sz="900" noProof="0" dirty="0"/>
-          </a:p>
-        </p:txBody>
-      </p:sp>
-      <p:sp>
-        <p:nvSpPr>
           <p:cNvPr id="51" name="Obs B.13">
             <a:extLst>
               <a:ext uri="{FF2B5EF4-FFF2-40B4-BE49-F238E27FC236}">
@@ -7723,56 +7724,6 @@
       </p:sp>
       <p:sp>
         <p:nvSpPr>
-          <p:cNvPr id="61" name="Comentario B.13">
-            <a:extLst>
-              <a:ext uri="{FF2B5EF4-FFF2-40B4-BE49-F238E27FC236}">
-                <a16:creationId xmlns:a16="http://schemas.microsoft.com/office/drawing/2014/main" id="{1778DD00-7DE2-1F2A-0F49-F55A618C20CA}"/>
-              </a:ext>
-            </a:extLst>
-          </p:cNvPr>
-          <p:cNvSpPr txBox="1"/>
-          <p:nvPr/>
-        </p:nvSpPr>
-        <p:spPr>
-          <a:xfrm>
-            <a:off x="603504" y="5786751"/>
-            <a:ext cx="3472587" cy="244602"/>
-          </a:xfrm>
-          <a:prstGeom prst="rect">
-            <a:avLst/>
-          </a:prstGeom>
-          <a:noFill/>
-          <a:ln/>
-        </p:spPr>
-        <p:txBody>
-          <a:bodyPr wrap="square" lIns="0" tIns="0" rIns="0" bIns="0" rtlCol="0" anchor="t"/>
-          <a:lstStyle/>
-          <a:p>
-            <a:pPr marL="0" indent="0" algn="just">
-              <a:buNone/>
-            </a:pPr>
-            <a:r>
-              <a:rPr lang="es-SV" sz="900" b="1" noProof="0" dirty="0">
-                <a:solidFill>
-                  <a:schemeClr val="accent5"/>
-                </a:solidFill>
-              </a:rPr>
-              <a:t>Comentarios  </a:t>
-            </a:r>
-            <a:r>
-              <a:rPr lang="es-SV" sz="900" b="1" noProof="0" dirty="0">
-                <a:solidFill>
-                  <a:schemeClr val="accent6"/>
-                </a:solidFill>
-              </a:rPr>
-              <a:t>Pendiente</a:t>
-            </a:r>
-            <a:endParaRPr lang="es-SV" sz="900" noProof="0" dirty="0"/>
-          </a:p>
-        </p:txBody>
-      </p:sp>
-      <p:sp>
-        <p:nvSpPr>
           <p:cNvPr id="63" name="Obs B.14">
             <a:extLst>
               <a:ext uri="{FF2B5EF4-FFF2-40B4-BE49-F238E27FC236}">
@@ -7998,56 +7949,6 @@
       </p:sp>
       <p:sp>
         <p:nvSpPr>
-          <p:cNvPr id="73" name="Comentario B.14">
-            <a:extLst>
-              <a:ext uri="{FF2B5EF4-FFF2-40B4-BE49-F238E27FC236}">
-                <a16:creationId xmlns:a16="http://schemas.microsoft.com/office/drawing/2014/main" id="{041A7782-0E39-F35E-66F5-D44C6BF668E7}"/>
-              </a:ext>
-            </a:extLst>
-          </p:cNvPr>
-          <p:cNvSpPr txBox="1"/>
-          <p:nvPr/>
-        </p:nvSpPr>
-        <p:spPr>
-          <a:xfrm>
-            <a:off x="4368698" y="5953177"/>
-            <a:ext cx="3381147" cy="234143"/>
-          </a:xfrm>
-          <a:prstGeom prst="rect">
-            <a:avLst/>
-          </a:prstGeom>
-          <a:noFill/>
-          <a:ln/>
-        </p:spPr>
-        <p:txBody>
-          <a:bodyPr wrap="square" lIns="0" tIns="0" rIns="0" bIns="0" rtlCol="0" anchor="t"/>
-          <a:lstStyle/>
-          <a:p>
-            <a:pPr marL="0" indent="0" algn="just">
-              <a:buNone/>
-            </a:pPr>
-            <a:r>
-              <a:rPr lang="es-SV" sz="900" b="1" noProof="0" dirty="0">
-                <a:solidFill>
-                  <a:schemeClr val="accent5"/>
-                </a:solidFill>
-              </a:rPr>
-              <a:t>Comentarios  </a:t>
-            </a:r>
-            <a:r>
-              <a:rPr lang="es-SV" sz="900" b="1" noProof="0" dirty="0">
-                <a:solidFill>
-                  <a:schemeClr val="accent6"/>
-                </a:solidFill>
-              </a:rPr>
-              <a:t>Pendiente</a:t>
-            </a:r>
-            <a:endParaRPr lang="es-SV" sz="900" noProof="0" dirty="0"/>
-          </a:p>
-        </p:txBody>
-      </p:sp>
-      <p:sp>
-        <p:nvSpPr>
           <p:cNvPr id="75" name="Obs B.15">
             <a:extLst>
               <a:ext uri="{FF2B5EF4-FFF2-40B4-BE49-F238E27FC236}">
@@ -8318,6 +8219,270 @@
               <a:t>Como parte del fortalecimiento de los controles de seguridad asociados al servicio tercerizado del módulo ACRM, la Unidad de Seguridad de la Información y Ciberseguridad realizará una reevaluación de los riesgos de seguridad de la información y ciberseguridad, mediante la actualización de la matriz de riesgos y la revisión de los controles existentes, con el propósito de identificar oportunidades de mejora y definir las medidas adicionales de tratamiento que correspondan, en coordinación con el área responsable de la solución el proveedor. Fecha de cumplimiento: 30 de noviembre de 2026.</a:t>
             </a:r>
             <a:endParaRPr lang="es-SV" sz="900" noProof="0" dirty="0"/>
+          </a:p>
+        </p:txBody>
+      </p:sp>
+      <p:sp>
+        <p:nvSpPr>
+          <p:cNvPr id="38" name="Comentario A.1">
+            <a:extLst>
+              <a:ext uri="{FF2B5EF4-FFF2-40B4-BE49-F238E27FC236}">
+                <a16:creationId xmlns:a16="http://schemas.microsoft.com/office/drawing/2014/main" id="{13EC3108-D2E2-ABA5-84F7-0A4290006269}"/>
+              </a:ext>
+            </a:extLst>
+          </p:cNvPr>
+          <p:cNvSpPr txBox="1"/>
+          <p:nvPr/>
+        </p:nvSpPr>
+        <p:spPr>
+          <a:xfrm>
+            <a:off x="1563090" y="2559209"/>
+            <a:ext cx="5282032" cy="200580"/>
+          </a:xfrm>
+          <a:prstGeom prst="rect">
+            <a:avLst/>
+          </a:prstGeom>
+          <a:noFill/>
+          <a:ln/>
+        </p:spPr>
+        <p:txBody>
+          <a:bodyPr wrap="square" lIns="0" tIns="0" rIns="0" bIns="0" rtlCol="0" anchor="t"/>
+          <a:lstStyle/>
+          <a:p>
+            <a:pPr algn="just"/>
+            <a:endParaRPr lang="es-SV" sz="900" dirty="0"/>
+          </a:p>
+        </p:txBody>
+      </p:sp>
+      <p:sp>
+        <p:nvSpPr>
+          <p:cNvPr id="46" name="Comentario A.1">
+            <a:extLst>
+              <a:ext uri="{FF2B5EF4-FFF2-40B4-BE49-F238E27FC236}">
+                <a16:creationId xmlns:a16="http://schemas.microsoft.com/office/drawing/2014/main" id="{4B90A5B3-C172-66B6-E9A2-B1CD3B7B4A89}"/>
+              </a:ext>
+            </a:extLst>
+          </p:cNvPr>
+          <p:cNvSpPr txBox="1"/>
+          <p:nvPr/>
+        </p:nvSpPr>
+        <p:spPr>
+          <a:xfrm>
+            <a:off x="4368698" y="4230414"/>
+            <a:ext cx="2155194" cy="178857"/>
+          </a:xfrm>
+          <a:prstGeom prst="rect">
+            <a:avLst/>
+          </a:prstGeom>
+          <a:noFill/>
+          <a:ln/>
+        </p:spPr>
+        <p:txBody>
+          <a:bodyPr wrap="square" lIns="0" tIns="0" rIns="0" bIns="0" rtlCol="0" anchor="t"/>
+          <a:lstStyle/>
+          <a:p>
+            <a:pPr algn="just"/>
+            <a:r>
+              <a:rPr lang="es-SV" sz="850" b="1" noProof="0" dirty="0">
+                <a:solidFill>
+                  <a:schemeClr val="accent5"/>
+                </a:solidFill>
+              </a:rPr>
+              <a:t>Comentarios  </a:t>
+            </a:r>
+            <a:r>
+              <a:rPr lang="es-SV" sz="800" b="1" dirty="0">
+                <a:solidFill>
+                  <a:schemeClr val="accent4">
+                    <a:lumMod val="75000"/>
+                  </a:schemeClr>
+                </a:solidFill>
+              </a:rPr>
+              <a:t>Se incorporará prueba de descargo</a:t>
+            </a:r>
+            <a:r>
+              <a:rPr lang="es-SV" sz="850" b="1" dirty="0">
+                <a:solidFill>
+                  <a:schemeClr val="accent6"/>
+                </a:solidFill>
+              </a:rPr>
+              <a:t> </a:t>
+            </a:r>
+            <a:endParaRPr lang="es-SV" sz="850" noProof="0" dirty="0"/>
+          </a:p>
+        </p:txBody>
+      </p:sp>
+      <p:sp>
+        <p:nvSpPr>
+          <p:cNvPr id="48" name="Comentario A.1">
+            <a:extLst>
+              <a:ext uri="{FF2B5EF4-FFF2-40B4-BE49-F238E27FC236}">
+                <a16:creationId xmlns:a16="http://schemas.microsoft.com/office/drawing/2014/main" id="{DA95FAFD-24DF-C7BD-C69F-D99325BA2A2F}"/>
+              </a:ext>
+            </a:extLst>
+          </p:cNvPr>
+          <p:cNvSpPr txBox="1"/>
+          <p:nvPr/>
+        </p:nvSpPr>
+        <p:spPr>
+          <a:xfrm>
+            <a:off x="8225332" y="4242900"/>
+            <a:ext cx="2155194" cy="178857"/>
+          </a:xfrm>
+          <a:prstGeom prst="rect">
+            <a:avLst/>
+          </a:prstGeom>
+          <a:noFill/>
+          <a:ln/>
+        </p:spPr>
+        <p:txBody>
+          <a:bodyPr wrap="square" lIns="0" tIns="0" rIns="0" bIns="0" rtlCol="0" anchor="t"/>
+          <a:lstStyle/>
+          <a:p>
+            <a:pPr algn="just"/>
+            <a:r>
+              <a:rPr lang="es-SV" sz="850" b="1" noProof="0" dirty="0">
+                <a:solidFill>
+                  <a:schemeClr val="accent5"/>
+                </a:solidFill>
+              </a:rPr>
+              <a:t>Comentarios  </a:t>
+            </a:r>
+            <a:r>
+              <a:rPr lang="es-SV" sz="800" b="1" dirty="0">
+                <a:solidFill>
+                  <a:schemeClr val="accent4">
+                    <a:lumMod val="75000"/>
+                  </a:schemeClr>
+                </a:solidFill>
+              </a:rPr>
+              <a:t>Se incorporará prueba de descargo</a:t>
+            </a:r>
+            <a:r>
+              <a:rPr lang="es-SV" sz="850" b="1" dirty="0">
+                <a:solidFill>
+                  <a:schemeClr val="accent6"/>
+                </a:solidFill>
+              </a:rPr>
+              <a:t> </a:t>
+            </a:r>
+            <a:endParaRPr lang="es-SV" sz="850" noProof="0" dirty="0"/>
+          </a:p>
+        </p:txBody>
+      </p:sp>
+      <p:sp>
+        <p:nvSpPr>
+          <p:cNvPr id="50" name="Comentario A.1">
+            <a:extLst>
+              <a:ext uri="{FF2B5EF4-FFF2-40B4-BE49-F238E27FC236}">
+                <a16:creationId xmlns:a16="http://schemas.microsoft.com/office/drawing/2014/main" id="{BACCCB29-F3B4-DA51-1EE1-C7677F068445}"/>
+              </a:ext>
+            </a:extLst>
+          </p:cNvPr>
+          <p:cNvSpPr txBox="1"/>
+          <p:nvPr/>
+        </p:nvSpPr>
+        <p:spPr>
+          <a:xfrm>
+            <a:off x="603504" y="5910370"/>
+            <a:ext cx="2155194" cy="178857"/>
+          </a:xfrm>
+          <a:prstGeom prst="rect">
+            <a:avLst/>
+          </a:prstGeom>
+          <a:noFill/>
+          <a:ln/>
+        </p:spPr>
+        <p:txBody>
+          <a:bodyPr wrap="square" lIns="0" tIns="0" rIns="0" bIns="0" rtlCol="0" anchor="t"/>
+          <a:lstStyle/>
+          <a:p>
+            <a:pPr algn="just"/>
+            <a:r>
+              <a:rPr lang="es-SV" sz="850" b="1" noProof="0" dirty="0">
+                <a:solidFill>
+                  <a:schemeClr val="accent5"/>
+                </a:solidFill>
+              </a:rPr>
+              <a:t>Comentarios  </a:t>
+            </a:r>
+            <a:r>
+              <a:rPr lang="es-SV" sz="800" b="1" dirty="0">
+                <a:solidFill>
+                  <a:schemeClr val="accent4">
+                    <a:lumMod val="75000"/>
+                  </a:schemeClr>
+                </a:solidFill>
+              </a:rPr>
+              <a:t>Se incorporará prueba de descargo</a:t>
+            </a:r>
+            <a:r>
+              <a:rPr lang="es-SV" sz="850" b="1" dirty="0">
+                <a:solidFill>
+                  <a:schemeClr val="accent6"/>
+                </a:solidFill>
+              </a:rPr>
+              <a:t> </a:t>
+            </a:r>
+            <a:endParaRPr lang="es-SV" sz="850" noProof="0" dirty="0"/>
+          </a:p>
+        </p:txBody>
+      </p:sp>
+      <p:sp>
+        <p:nvSpPr>
+          <p:cNvPr id="52" name="Comentario A.1">
+            <a:extLst>
+              <a:ext uri="{FF2B5EF4-FFF2-40B4-BE49-F238E27FC236}">
+                <a16:creationId xmlns:a16="http://schemas.microsoft.com/office/drawing/2014/main" id="{53F16EA7-1A14-47CF-3C4A-375F06C00A99}"/>
+              </a:ext>
+            </a:extLst>
+          </p:cNvPr>
+          <p:cNvSpPr txBox="1"/>
+          <p:nvPr/>
+        </p:nvSpPr>
+        <p:spPr>
+          <a:xfrm>
+            <a:off x="4405275" y="5950273"/>
+            <a:ext cx="2155194" cy="178857"/>
+          </a:xfrm>
+          <a:prstGeom prst="rect">
+            <a:avLst/>
+          </a:prstGeom>
+          <a:noFill/>
+          <a:ln/>
+        </p:spPr>
+        <p:txBody>
+          <a:bodyPr wrap="square" lIns="0" tIns="0" rIns="0" bIns="0" rtlCol="0" anchor="t"/>
+          <a:lstStyle/>
+          <a:p>
+            <a:pPr algn="just"/>
+            <a:r>
+              <a:rPr lang="es-SV" sz="850" b="1" noProof="0" dirty="0">
+                <a:solidFill>
+                  <a:schemeClr val="accent5"/>
+                </a:solidFill>
+              </a:rPr>
+              <a:t>Comentarios  </a:t>
+            </a:r>
+            <a:r>
+              <a:rPr lang="es-SV" sz="800" b="1" dirty="0">
+                <a:solidFill>
+                  <a:schemeClr val="accent4">
+                    <a:lumMod val="75000"/>
+                  </a:schemeClr>
+                </a:solidFill>
+              </a:rPr>
+              <a:t>Se incorporará prueba de descargo</a:t>
+            </a:r>
+            <a:r>
+              <a:rPr lang="es-SV" sz="850" b="1" dirty="0">
+                <a:solidFill>
+                  <a:schemeClr val="accent6"/>
+                </a:solidFill>
+              </a:rPr>
+              <a:t> </a:t>
+            </a:r>
+            <a:endParaRPr lang="es-SV" sz="850" noProof="0" dirty="0"/>
           </a:p>
         </p:txBody>
       </p:sp>
@@ -11202,7 +11367,7 @@
           </a:prstGeom>
           <a:extLst>
             <a:ext uri="{C572A759-6A51-4108-AA02-DFA0A04FC94B}">
-              <ma14:wrappingTextBoxFlag xmlns="" xmlns:ma14="http://schemas.microsoft.com/office/mac/drawingml/2011/main" val="0"/>
+              <ma14:wrappingTextBoxFlag xmlns:ma14="http://schemas.microsoft.com/office/mac/drawingml/2011/main" xmlns="" val="0"/>
             </a:ext>
           </a:extLst>
         </p:spPr>

</xml_diff>